<commit_message>
feat: Implement Gantt chart rendering with Mermaid support
- Add GanttRenderer class to render Gantt charts on PPTX slides.
- Introduce GanttParser for parsing Mermaid Gantt syntax.
- Enhance MermaidRenderer to support Gantt diagrams.
- Update demo QMD file with a comprehensive Gantt chart example.
- Create unit tests for GanttParser and GanttRenderer functionalities.
</commit_message>
<xml_diff>
--- a/demo_full.pptx
+++ b/demo_full.pptx
@@ -9602,7 +9602,7 @@
           <a:lstStyle/>
           <a:p>
             <a:r>
-              <a:t>3. ガントチャート（Gantt Diagram）</a:t>
+              <a:t>3. ガントチャート（Gantt Diagram）— 全タグ・after参照デモ</a:t>
             </a:r>
           </a:p>
         </p:txBody>
@@ -9624,45 +9624,1612 @@
           <a:p/>
         </p:txBody>
       </p:sp>
-      <p:sp>
-        <p:nvSpPr>
-          <p:cNvPr id="4" name="TextBox 3"/>
-          <p:cNvSpPr txBox="1"/>
-          <p:nvPr/>
-        </p:nvSpPr>
-        <p:spPr>
-          <a:xfrm>
-            <a:off x="457200" y="1600200"/>
-            <a:ext cx="8229600" cy="4525963"/>
-          </a:xfrm>
-          <a:prstGeom prst="rect">
-            <a:avLst/>
-          </a:prstGeom>
-          <a:noFill/>
-        </p:spPr>
-        <p:txBody>
-          <a:bodyPr wrap="square">
-            <a:spAutoFit/>
-          </a:bodyPr>
-          <a:lstStyle/>
-          <a:p>
-            <a:r>
-              <a:rPr sz="1000">
-                <a:latin typeface="Courier New"/>
-              </a:rPr>
-              <a:t>gantt
-    title プロジェクト計画
-    dateFormat YYYY-MM-DD
-    section 設計
-        要件定義  :done, des1, 2024-01-01, 2024-01-07
-        基本設計  :done, des2, 2024-01-08, 7d
-    section 実装
-        コーディング :active, dev1, 2024-01-15, 14d
-        テスト       :        dev2, after dev1, 7d
-    section リリース
-        デプロイ :milestone, 2024-02-05, 1d</a:t>
-            </a:r>
-          </a:p>
+      <p:graphicFrame>
+        <p:nvGraphicFramePr>
+          <p:cNvPr id="4" name="Table 3"/>
+          <p:cNvGraphicFramePr>
+            <a:graphicFrameLocks noGrp="1"/>
+          </p:cNvGraphicFramePr>
+          <p:nvPr/>
+        </p:nvGraphicFramePr>
+        <p:xfrm>
+          <a:off x="457200" y="1600200"/>
+          <a:ext cx="8229600" cy="4525956"/>
+        </p:xfrm>
+        <a:graphic>
+          <a:graphicData uri="http://schemas.openxmlformats.org/drawingml/2006/table">
+            <a:tbl>
+              <a:tblPr firstRow="1" bandRow="1">
+                <a:tableStyleId>{5C22544A-7EE6-4342-B048-85BDC9FD1C3A}</a:tableStyleId>
+              </a:tblPr>
+              <a:tblGrid>
+                <a:gridCol w="1810512"/>
+                <a:gridCol w="713232"/>
+                <a:gridCol w="713232"/>
+                <a:gridCol w="713232"/>
+                <a:gridCol w="713232"/>
+                <a:gridCol w="713232"/>
+                <a:gridCol w="713232"/>
+                <a:gridCol w="713232"/>
+                <a:gridCol w="713232"/>
+                <a:gridCol w="713232"/>
+              </a:tblGrid>
+              <a:tr h="377163">
+                <a:tc>
+                  <a:txBody>
+                    <a:bodyPr wrap="none"/>
+                    <a:lstStyle/>
+                    <a:p>
+                      <a:pPr algn="ctr"/>
+                      <a:r>
+                        <a:rPr sz="900" b="1">
+                          <a:solidFill>
+                            <a:srgbClr val="FFFFFF"/>
+                          </a:solidFill>
+                        </a:rPr>
+                        <a:t>タスク</a:t>
+                      </a:r>
+                    </a:p>
+                  </a:txBody>
+                  <a:tcPr>
+                    <a:solidFill>
+                      <a:srgbClr val="282850"/>
+                    </a:solidFill>
+                  </a:tcPr>
+                </a:tc>
+                <a:tc>
+                  <a:txBody>
+                    <a:bodyPr wrap="none"/>
+                    <a:lstStyle/>
+                    <a:p>
+                      <a:pPr algn="ctr"/>
+                      <a:r>
+                        <a:rPr sz="700" b="1">
+                          <a:solidFill>
+                            <a:srgbClr val="FFFFFF"/>
+                          </a:solidFill>
+                        </a:rPr>
+                        <a:t>01/01</a:t>
+                      </a:r>
+                    </a:p>
+                  </a:txBody>
+                  <a:tcPr>
+                    <a:solidFill>
+                      <a:srgbClr val="282850"/>
+                    </a:solidFill>
+                  </a:tcPr>
+                </a:tc>
+                <a:tc>
+                  <a:txBody>
+                    <a:bodyPr wrap="none"/>
+                    <a:lstStyle/>
+                    <a:p>
+                      <a:pPr algn="ctr"/>
+                      <a:r>
+                        <a:rPr sz="700" b="1">
+                          <a:solidFill>
+                            <a:srgbClr val="FFFFFF"/>
+                          </a:solidFill>
+                        </a:rPr>
+                        <a:t>01/08</a:t>
+                      </a:r>
+                    </a:p>
+                  </a:txBody>
+                  <a:tcPr>
+                    <a:solidFill>
+                      <a:srgbClr val="282850"/>
+                    </a:solidFill>
+                  </a:tcPr>
+                </a:tc>
+                <a:tc>
+                  <a:txBody>
+                    <a:bodyPr wrap="none"/>
+                    <a:lstStyle/>
+                    <a:p>
+                      <a:pPr algn="ctr"/>
+                      <a:r>
+                        <a:rPr sz="700" b="1">
+                          <a:solidFill>
+                            <a:srgbClr val="FFFFFF"/>
+                          </a:solidFill>
+                        </a:rPr>
+                        <a:t>01/15</a:t>
+                      </a:r>
+                    </a:p>
+                  </a:txBody>
+                  <a:tcPr>
+                    <a:solidFill>
+                      <a:srgbClr val="282850"/>
+                    </a:solidFill>
+                  </a:tcPr>
+                </a:tc>
+                <a:tc>
+                  <a:txBody>
+                    <a:bodyPr wrap="none"/>
+                    <a:lstStyle/>
+                    <a:p>
+                      <a:pPr algn="ctr"/>
+                      <a:r>
+                        <a:rPr sz="700" b="1">
+                          <a:solidFill>
+                            <a:srgbClr val="FFFFFF"/>
+                          </a:solidFill>
+                        </a:rPr>
+                        <a:t>01/22</a:t>
+                      </a:r>
+                    </a:p>
+                  </a:txBody>
+                  <a:tcPr>
+                    <a:solidFill>
+                      <a:srgbClr val="282850"/>
+                    </a:solidFill>
+                  </a:tcPr>
+                </a:tc>
+                <a:tc>
+                  <a:txBody>
+                    <a:bodyPr wrap="none"/>
+                    <a:lstStyle/>
+                    <a:p>
+                      <a:pPr algn="ctr"/>
+                      <a:r>
+                        <a:rPr sz="700" b="1">
+                          <a:solidFill>
+                            <a:srgbClr val="FFFFFF"/>
+                          </a:solidFill>
+                        </a:rPr>
+                        <a:t>01/29</a:t>
+                      </a:r>
+                    </a:p>
+                  </a:txBody>
+                  <a:tcPr>
+                    <a:solidFill>
+                      <a:srgbClr val="282850"/>
+                    </a:solidFill>
+                  </a:tcPr>
+                </a:tc>
+                <a:tc>
+                  <a:txBody>
+                    <a:bodyPr wrap="none"/>
+                    <a:lstStyle/>
+                    <a:p>
+                      <a:pPr algn="ctr"/>
+                      <a:r>
+                        <a:rPr sz="700" b="1">
+                          <a:solidFill>
+                            <a:srgbClr val="FFFFFF"/>
+                          </a:solidFill>
+                        </a:rPr>
+                        <a:t>02/05</a:t>
+                      </a:r>
+                    </a:p>
+                  </a:txBody>
+                  <a:tcPr>
+                    <a:solidFill>
+                      <a:srgbClr val="282850"/>
+                    </a:solidFill>
+                  </a:tcPr>
+                </a:tc>
+                <a:tc>
+                  <a:txBody>
+                    <a:bodyPr wrap="none"/>
+                    <a:lstStyle/>
+                    <a:p>
+                      <a:pPr algn="ctr"/>
+                      <a:r>
+                        <a:rPr sz="700" b="1">
+                          <a:solidFill>
+                            <a:srgbClr val="FFFFFF"/>
+                          </a:solidFill>
+                        </a:rPr>
+                        <a:t>02/12</a:t>
+                      </a:r>
+                    </a:p>
+                  </a:txBody>
+                  <a:tcPr>
+                    <a:solidFill>
+                      <a:srgbClr val="282850"/>
+                    </a:solidFill>
+                  </a:tcPr>
+                </a:tc>
+                <a:tc>
+                  <a:txBody>
+                    <a:bodyPr wrap="none"/>
+                    <a:lstStyle/>
+                    <a:p>
+                      <a:pPr algn="ctr"/>
+                      <a:r>
+                        <a:rPr sz="700" b="1">
+                          <a:solidFill>
+                            <a:srgbClr val="FFFFFF"/>
+                          </a:solidFill>
+                        </a:rPr>
+                        <a:t>02/19</a:t>
+                      </a:r>
+                    </a:p>
+                  </a:txBody>
+                  <a:tcPr>
+                    <a:solidFill>
+                      <a:srgbClr val="282850"/>
+                    </a:solidFill>
+                  </a:tcPr>
+                </a:tc>
+                <a:tc>
+                  <a:txBody>
+                    <a:bodyPr wrap="none"/>
+                    <a:lstStyle/>
+                    <a:p>
+                      <a:pPr algn="ctr"/>
+                      <a:r>
+                        <a:rPr sz="700" b="1">
+                          <a:solidFill>
+                            <a:srgbClr val="FFFFFF"/>
+                          </a:solidFill>
+                        </a:rPr>
+                        <a:t>02/26</a:t>
+                      </a:r>
+                    </a:p>
+                  </a:txBody>
+                  <a:tcPr>
+                    <a:solidFill>
+                      <a:srgbClr val="282850"/>
+                    </a:solidFill>
+                  </a:tcPr>
+                </a:tc>
+              </a:tr>
+              <a:tr h="377163">
+                <a:tc gridSpan="10">
+                  <a:txBody>
+                    <a:bodyPr wrap="none"/>
+                    <a:lstStyle/>
+                    <a:p>
+                      <a:pPr algn="l"/>
+                      <a:r>
+                        <a:rPr sz="1000" b="1">
+                          <a:solidFill>
+                            <a:srgbClr val="FFFFFF"/>
+                          </a:solidFill>
+                        </a:rPr>
+                        <a:t>  設計フェーズ</a:t>
+                      </a:r>
+                    </a:p>
+                  </a:txBody>
+                  <a:tcPr>
+                    <a:solidFill>
+                      <a:srgbClr val="3C3C6E"/>
+                    </a:solidFill>
+                  </a:tcPr>
+                </a:tc>
+                <a:tc hMerge="1">
+                  <a:txBody>
+                    <a:bodyPr/>
+                    <a:lstStyle/>
+                    <a:p/>
+                  </a:txBody>
+                  <a:tcPr/>
+                </a:tc>
+                <a:tc hMerge="1">
+                  <a:txBody>
+                    <a:bodyPr/>
+                    <a:lstStyle/>
+                    <a:p/>
+                  </a:txBody>
+                  <a:tcPr/>
+                </a:tc>
+                <a:tc hMerge="1">
+                  <a:txBody>
+                    <a:bodyPr/>
+                    <a:lstStyle/>
+                    <a:p/>
+                  </a:txBody>
+                  <a:tcPr/>
+                </a:tc>
+                <a:tc hMerge="1">
+                  <a:txBody>
+                    <a:bodyPr/>
+                    <a:lstStyle/>
+                    <a:p/>
+                  </a:txBody>
+                  <a:tcPr/>
+                </a:tc>
+                <a:tc hMerge="1">
+                  <a:txBody>
+                    <a:bodyPr/>
+                    <a:lstStyle/>
+                    <a:p/>
+                  </a:txBody>
+                  <a:tcPr/>
+                </a:tc>
+                <a:tc hMerge="1">
+                  <a:txBody>
+                    <a:bodyPr/>
+                    <a:lstStyle/>
+                    <a:p/>
+                  </a:txBody>
+                  <a:tcPr/>
+                </a:tc>
+                <a:tc hMerge="1">
+                  <a:txBody>
+                    <a:bodyPr/>
+                    <a:lstStyle/>
+                    <a:p/>
+                  </a:txBody>
+                  <a:tcPr/>
+                </a:tc>
+                <a:tc hMerge="1">
+                  <a:txBody>
+                    <a:bodyPr/>
+                    <a:lstStyle/>
+                    <a:p/>
+                  </a:txBody>
+                  <a:tcPr/>
+                </a:tc>
+                <a:tc hMerge="1">
+                  <a:txBody>
+                    <a:bodyPr/>
+                    <a:lstStyle/>
+                    <a:p/>
+                  </a:txBody>
+                  <a:tcPr/>
+                </a:tc>
+              </a:tr>
+              <a:tr h="377163">
+                <a:tc>
+                  <a:txBody>
+                    <a:bodyPr wrap="none"/>
+                    <a:lstStyle/>
+                    <a:p>
+                      <a:pPr algn="l"/>
+                      <a:r>
+                        <a:rPr sz="900" b="0"/>
+                        <a:t> 要件定義</a:t>
+                      </a:r>
+                    </a:p>
+                  </a:txBody>
+                  <a:tcPr>
+                    <a:solidFill>
+                      <a:srgbClr val="F5F5FA"/>
+                    </a:solidFill>
+                  </a:tcPr>
+                </a:tc>
+                <a:tc>
+                  <a:txBody>
+                    <a:bodyPr/>
+                    <a:lstStyle/>
+                    <a:p/>
+                  </a:txBody>
+                  <a:tcPr/>
+                </a:tc>
+                <a:tc>
+                  <a:txBody>
+                    <a:bodyPr/>
+                    <a:lstStyle/>
+                    <a:p/>
+                  </a:txBody>
+                  <a:tcPr/>
+                </a:tc>
+                <a:tc>
+                  <a:txBody>
+                    <a:bodyPr/>
+                    <a:lstStyle/>
+                    <a:p/>
+                  </a:txBody>
+                  <a:tcPr/>
+                </a:tc>
+                <a:tc>
+                  <a:txBody>
+                    <a:bodyPr/>
+                    <a:lstStyle/>
+                    <a:p/>
+                  </a:txBody>
+                  <a:tcPr/>
+                </a:tc>
+                <a:tc>
+                  <a:txBody>
+                    <a:bodyPr/>
+                    <a:lstStyle/>
+                    <a:p/>
+                  </a:txBody>
+                  <a:tcPr/>
+                </a:tc>
+                <a:tc>
+                  <a:txBody>
+                    <a:bodyPr/>
+                    <a:lstStyle/>
+                    <a:p/>
+                  </a:txBody>
+                  <a:tcPr/>
+                </a:tc>
+                <a:tc>
+                  <a:txBody>
+                    <a:bodyPr/>
+                    <a:lstStyle/>
+                    <a:p/>
+                  </a:txBody>
+                  <a:tcPr/>
+                </a:tc>
+                <a:tc>
+                  <a:txBody>
+                    <a:bodyPr/>
+                    <a:lstStyle/>
+                    <a:p/>
+                  </a:txBody>
+                  <a:tcPr/>
+                </a:tc>
+                <a:tc>
+                  <a:txBody>
+                    <a:bodyPr/>
+                    <a:lstStyle/>
+                    <a:p/>
+                  </a:txBody>
+                  <a:tcPr/>
+                </a:tc>
+              </a:tr>
+              <a:tr h="377163">
+                <a:tc>
+                  <a:txBody>
+                    <a:bodyPr wrap="none"/>
+                    <a:lstStyle/>
+                    <a:p>
+                      <a:pPr algn="l"/>
+                      <a:r>
+                        <a:rPr sz="900" b="0"/>
+                        <a:t> 基本設計</a:t>
+                      </a:r>
+                    </a:p>
+                  </a:txBody>
+                  <a:tcPr>
+                    <a:solidFill>
+                      <a:srgbClr val="F5F5FA"/>
+                    </a:solidFill>
+                  </a:tcPr>
+                </a:tc>
+                <a:tc>
+                  <a:txBody>
+                    <a:bodyPr/>
+                    <a:lstStyle/>
+                    <a:p/>
+                  </a:txBody>
+                  <a:tcPr/>
+                </a:tc>
+                <a:tc>
+                  <a:txBody>
+                    <a:bodyPr/>
+                    <a:lstStyle/>
+                    <a:p/>
+                  </a:txBody>
+                  <a:tcPr/>
+                </a:tc>
+                <a:tc>
+                  <a:txBody>
+                    <a:bodyPr/>
+                    <a:lstStyle/>
+                    <a:p/>
+                  </a:txBody>
+                  <a:tcPr/>
+                </a:tc>
+                <a:tc>
+                  <a:txBody>
+                    <a:bodyPr/>
+                    <a:lstStyle/>
+                    <a:p/>
+                  </a:txBody>
+                  <a:tcPr/>
+                </a:tc>
+                <a:tc>
+                  <a:txBody>
+                    <a:bodyPr/>
+                    <a:lstStyle/>
+                    <a:p/>
+                  </a:txBody>
+                  <a:tcPr/>
+                </a:tc>
+                <a:tc>
+                  <a:txBody>
+                    <a:bodyPr/>
+                    <a:lstStyle/>
+                    <a:p/>
+                  </a:txBody>
+                  <a:tcPr/>
+                </a:tc>
+                <a:tc>
+                  <a:txBody>
+                    <a:bodyPr/>
+                    <a:lstStyle/>
+                    <a:p/>
+                  </a:txBody>
+                  <a:tcPr/>
+                </a:tc>
+                <a:tc>
+                  <a:txBody>
+                    <a:bodyPr/>
+                    <a:lstStyle/>
+                    <a:p/>
+                  </a:txBody>
+                  <a:tcPr/>
+                </a:tc>
+                <a:tc>
+                  <a:txBody>
+                    <a:bodyPr/>
+                    <a:lstStyle/>
+                    <a:p/>
+                  </a:txBody>
+                  <a:tcPr/>
+                </a:tc>
+              </a:tr>
+              <a:tr h="377163">
+                <a:tc>
+                  <a:txBody>
+                    <a:bodyPr wrap="none"/>
+                    <a:lstStyle/>
+                    <a:p>
+                      <a:pPr algn="l"/>
+                      <a:r>
+                        <a:rPr sz="900" b="0"/>
+                        <a:t> 詳細設計</a:t>
+                      </a:r>
+                    </a:p>
+                  </a:txBody>
+                  <a:tcPr>
+                    <a:solidFill>
+                      <a:srgbClr val="F5F5FA"/>
+                    </a:solidFill>
+                  </a:tcPr>
+                </a:tc>
+                <a:tc>
+                  <a:txBody>
+                    <a:bodyPr/>
+                    <a:lstStyle/>
+                    <a:p/>
+                  </a:txBody>
+                  <a:tcPr/>
+                </a:tc>
+                <a:tc>
+                  <a:txBody>
+                    <a:bodyPr/>
+                    <a:lstStyle/>
+                    <a:p/>
+                  </a:txBody>
+                  <a:tcPr/>
+                </a:tc>
+                <a:tc>
+                  <a:txBody>
+                    <a:bodyPr/>
+                    <a:lstStyle/>
+                    <a:p/>
+                  </a:txBody>
+                  <a:tcPr/>
+                </a:tc>
+                <a:tc>
+                  <a:txBody>
+                    <a:bodyPr/>
+                    <a:lstStyle/>
+                    <a:p/>
+                  </a:txBody>
+                  <a:tcPr/>
+                </a:tc>
+                <a:tc>
+                  <a:txBody>
+                    <a:bodyPr/>
+                    <a:lstStyle/>
+                    <a:p/>
+                  </a:txBody>
+                  <a:tcPr/>
+                </a:tc>
+                <a:tc>
+                  <a:txBody>
+                    <a:bodyPr/>
+                    <a:lstStyle/>
+                    <a:p/>
+                  </a:txBody>
+                  <a:tcPr/>
+                </a:tc>
+                <a:tc>
+                  <a:txBody>
+                    <a:bodyPr/>
+                    <a:lstStyle/>
+                    <a:p/>
+                  </a:txBody>
+                  <a:tcPr/>
+                </a:tc>
+                <a:tc>
+                  <a:txBody>
+                    <a:bodyPr/>
+                    <a:lstStyle/>
+                    <a:p/>
+                  </a:txBody>
+                  <a:tcPr/>
+                </a:tc>
+                <a:tc>
+                  <a:txBody>
+                    <a:bodyPr/>
+                    <a:lstStyle/>
+                    <a:p/>
+                  </a:txBody>
+                  <a:tcPr/>
+                </a:tc>
+              </a:tr>
+              <a:tr h="377163">
+                <a:tc gridSpan="10">
+                  <a:txBody>
+                    <a:bodyPr wrap="none"/>
+                    <a:lstStyle/>
+                    <a:p>
+                      <a:pPr algn="l"/>
+                      <a:r>
+                        <a:rPr sz="1000" b="1">
+                          <a:solidFill>
+                            <a:srgbClr val="FFFFFF"/>
+                          </a:solidFill>
+                        </a:rPr>
+                        <a:t>  実装フェーズ</a:t>
+                      </a:r>
+                    </a:p>
+                  </a:txBody>
+                  <a:tcPr>
+                    <a:solidFill>
+                      <a:srgbClr val="3C3C6E"/>
+                    </a:solidFill>
+                  </a:tcPr>
+                </a:tc>
+                <a:tc hMerge="1">
+                  <a:txBody>
+                    <a:bodyPr/>
+                    <a:lstStyle/>
+                    <a:p/>
+                  </a:txBody>
+                  <a:tcPr/>
+                </a:tc>
+                <a:tc hMerge="1">
+                  <a:txBody>
+                    <a:bodyPr/>
+                    <a:lstStyle/>
+                    <a:p/>
+                  </a:txBody>
+                  <a:tcPr/>
+                </a:tc>
+                <a:tc hMerge="1">
+                  <a:txBody>
+                    <a:bodyPr/>
+                    <a:lstStyle/>
+                    <a:p/>
+                  </a:txBody>
+                  <a:tcPr/>
+                </a:tc>
+                <a:tc hMerge="1">
+                  <a:txBody>
+                    <a:bodyPr/>
+                    <a:lstStyle/>
+                    <a:p/>
+                  </a:txBody>
+                  <a:tcPr/>
+                </a:tc>
+                <a:tc hMerge="1">
+                  <a:txBody>
+                    <a:bodyPr/>
+                    <a:lstStyle/>
+                    <a:p/>
+                  </a:txBody>
+                  <a:tcPr/>
+                </a:tc>
+                <a:tc hMerge="1">
+                  <a:txBody>
+                    <a:bodyPr/>
+                    <a:lstStyle/>
+                    <a:p/>
+                  </a:txBody>
+                  <a:tcPr/>
+                </a:tc>
+                <a:tc hMerge="1">
+                  <a:txBody>
+                    <a:bodyPr/>
+                    <a:lstStyle/>
+                    <a:p/>
+                  </a:txBody>
+                  <a:tcPr/>
+                </a:tc>
+                <a:tc hMerge="1">
+                  <a:txBody>
+                    <a:bodyPr/>
+                    <a:lstStyle/>
+                    <a:p/>
+                  </a:txBody>
+                  <a:tcPr/>
+                </a:tc>
+                <a:tc hMerge="1">
+                  <a:txBody>
+                    <a:bodyPr/>
+                    <a:lstStyle/>
+                    <a:p/>
+                  </a:txBody>
+                  <a:tcPr/>
+                </a:tc>
+              </a:tr>
+              <a:tr h="377163">
+                <a:tc>
+                  <a:txBody>
+                    <a:bodyPr wrap="none"/>
+                    <a:lstStyle/>
+                    <a:p>
+                      <a:pPr algn="l"/>
+                      <a:r>
+                        <a:rPr sz="900" b="0"/>
+                        <a:t> コーディング</a:t>
+                      </a:r>
+                    </a:p>
+                  </a:txBody>
+                  <a:tcPr>
+                    <a:solidFill>
+                      <a:srgbClr val="F5F5FA"/>
+                    </a:solidFill>
+                  </a:tcPr>
+                </a:tc>
+                <a:tc>
+                  <a:txBody>
+                    <a:bodyPr/>
+                    <a:lstStyle/>
+                    <a:p/>
+                  </a:txBody>
+                  <a:tcPr/>
+                </a:tc>
+                <a:tc>
+                  <a:txBody>
+                    <a:bodyPr/>
+                    <a:lstStyle/>
+                    <a:p/>
+                  </a:txBody>
+                  <a:tcPr/>
+                </a:tc>
+                <a:tc>
+                  <a:txBody>
+                    <a:bodyPr/>
+                    <a:lstStyle/>
+                    <a:p/>
+                  </a:txBody>
+                  <a:tcPr/>
+                </a:tc>
+                <a:tc>
+                  <a:txBody>
+                    <a:bodyPr/>
+                    <a:lstStyle/>
+                    <a:p/>
+                  </a:txBody>
+                  <a:tcPr/>
+                </a:tc>
+                <a:tc>
+                  <a:txBody>
+                    <a:bodyPr/>
+                    <a:lstStyle/>
+                    <a:p/>
+                  </a:txBody>
+                  <a:tcPr/>
+                </a:tc>
+                <a:tc>
+                  <a:txBody>
+                    <a:bodyPr/>
+                    <a:lstStyle/>
+                    <a:p/>
+                  </a:txBody>
+                  <a:tcPr/>
+                </a:tc>
+                <a:tc>
+                  <a:txBody>
+                    <a:bodyPr/>
+                    <a:lstStyle/>
+                    <a:p/>
+                  </a:txBody>
+                  <a:tcPr/>
+                </a:tc>
+                <a:tc>
+                  <a:txBody>
+                    <a:bodyPr/>
+                    <a:lstStyle/>
+                    <a:p/>
+                  </a:txBody>
+                  <a:tcPr/>
+                </a:tc>
+                <a:tc>
+                  <a:txBody>
+                    <a:bodyPr/>
+                    <a:lstStyle/>
+                    <a:p/>
+                  </a:txBody>
+                  <a:tcPr/>
+                </a:tc>
+              </a:tr>
+              <a:tr h="377163">
+                <a:tc>
+                  <a:txBody>
+                    <a:bodyPr wrap="none"/>
+                    <a:lstStyle/>
+                    <a:p>
+                      <a:pPr algn="l"/>
+                      <a:r>
+                        <a:rPr sz="900" b="0"/>
+                        <a:t> コードレビュー</a:t>
+                      </a:r>
+                    </a:p>
+                  </a:txBody>
+                  <a:tcPr>
+                    <a:solidFill>
+                      <a:srgbClr val="F5F5FA"/>
+                    </a:solidFill>
+                  </a:tcPr>
+                </a:tc>
+                <a:tc>
+                  <a:txBody>
+                    <a:bodyPr/>
+                    <a:lstStyle/>
+                    <a:p/>
+                  </a:txBody>
+                  <a:tcPr/>
+                </a:tc>
+                <a:tc>
+                  <a:txBody>
+                    <a:bodyPr/>
+                    <a:lstStyle/>
+                    <a:p/>
+                  </a:txBody>
+                  <a:tcPr/>
+                </a:tc>
+                <a:tc>
+                  <a:txBody>
+                    <a:bodyPr/>
+                    <a:lstStyle/>
+                    <a:p/>
+                  </a:txBody>
+                  <a:tcPr/>
+                </a:tc>
+                <a:tc>
+                  <a:txBody>
+                    <a:bodyPr/>
+                    <a:lstStyle/>
+                    <a:p/>
+                  </a:txBody>
+                  <a:tcPr/>
+                </a:tc>
+                <a:tc>
+                  <a:txBody>
+                    <a:bodyPr/>
+                    <a:lstStyle/>
+                    <a:p/>
+                  </a:txBody>
+                  <a:tcPr/>
+                </a:tc>
+                <a:tc>
+                  <a:txBody>
+                    <a:bodyPr/>
+                    <a:lstStyle/>
+                    <a:p/>
+                  </a:txBody>
+                  <a:tcPr/>
+                </a:tc>
+                <a:tc>
+                  <a:txBody>
+                    <a:bodyPr/>
+                    <a:lstStyle/>
+                    <a:p/>
+                  </a:txBody>
+                  <a:tcPr/>
+                </a:tc>
+                <a:tc>
+                  <a:txBody>
+                    <a:bodyPr/>
+                    <a:lstStyle/>
+                    <a:p/>
+                  </a:txBody>
+                  <a:tcPr/>
+                </a:tc>
+                <a:tc>
+                  <a:txBody>
+                    <a:bodyPr/>
+                    <a:lstStyle/>
+                    <a:p/>
+                  </a:txBody>
+                  <a:tcPr/>
+                </a:tc>
+              </a:tr>
+              <a:tr h="377163">
+                <a:tc>
+                  <a:txBody>
+                    <a:bodyPr wrap="none"/>
+                    <a:lstStyle/>
+                    <a:p>
+                      <a:pPr algn="l"/>
+                      <a:r>
+                        <a:rPr sz="900" b="0"/>
+                        <a:t> テスト</a:t>
+                      </a:r>
+                    </a:p>
+                  </a:txBody>
+                  <a:tcPr>
+                    <a:solidFill>
+                      <a:srgbClr val="F5F5FA"/>
+                    </a:solidFill>
+                  </a:tcPr>
+                </a:tc>
+                <a:tc>
+                  <a:txBody>
+                    <a:bodyPr/>
+                    <a:lstStyle/>
+                    <a:p/>
+                  </a:txBody>
+                  <a:tcPr/>
+                </a:tc>
+                <a:tc>
+                  <a:txBody>
+                    <a:bodyPr/>
+                    <a:lstStyle/>
+                    <a:p/>
+                  </a:txBody>
+                  <a:tcPr/>
+                </a:tc>
+                <a:tc>
+                  <a:txBody>
+                    <a:bodyPr/>
+                    <a:lstStyle/>
+                    <a:p/>
+                  </a:txBody>
+                  <a:tcPr/>
+                </a:tc>
+                <a:tc>
+                  <a:txBody>
+                    <a:bodyPr/>
+                    <a:lstStyle/>
+                    <a:p/>
+                  </a:txBody>
+                  <a:tcPr/>
+                </a:tc>
+                <a:tc>
+                  <a:txBody>
+                    <a:bodyPr/>
+                    <a:lstStyle/>
+                    <a:p/>
+                  </a:txBody>
+                  <a:tcPr/>
+                </a:tc>
+                <a:tc>
+                  <a:txBody>
+                    <a:bodyPr/>
+                    <a:lstStyle/>
+                    <a:p/>
+                  </a:txBody>
+                  <a:tcPr/>
+                </a:tc>
+                <a:tc>
+                  <a:txBody>
+                    <a:bodyPr/>
+                    <a:lstStyle/>
+                    <a:p/>
+                  </a:txBody>
+                  <a:tcPr/>
+                </a:tc>
+                <a:tc>
+                  <a:txBody>
+                    <a:bodyPr/>
+                    <a:lstStyle/>
+                    <a:p/>
+                  </a:txBody>
+                  <a:tcPr/>
+                </a:tc>
+                <a:tc>
+                  <a:txBody>
+                    <a:bodyPr/>
+                    <a:lstStyle/>
+                    <a:p/>
+                  </a:txBody>
+                  <a:tcPr/>
+                </a:tc>
+              </a:tr>
+              <a:tr h="377163">
+                <a:tc gridSpan="10">
+                  <a:txBody>
+                    <a:bodyPr wrap="none"/>
+                    <a:lstStyle/>
+                    <a:p>
+                      <a:pPr algn="l"/>
+                      <a:r>
+                        <a:rPr sz="1000" b="1">
+                          <a:solidFill>
+                            <a:srgbClr val="FFFFFF"/>
+                          </a:solidFill>
+                        </a:rPr>
+                        <a:t>  リリース</a:t>
+                      </a:r>
+                    </a:p>
+                  </a:txBody>
+                  <a:tcPr>
+                    <a:solidFill>
+                      <a:srgbClr val="3C3C6E"/>
+                    </a:solidFill>
+                  </a:tcPr>
+                </a:tc>
+                <a:tc hMerge="1">
+                  <a:txBody>
+                    <a:bodyPr/>
+                    <a:lstStyle/>
+                    <a:p/>
+                  </a:txBody>
+                  <a:tcPr/>
+                </a:tc>
+                <a:tc hMerge="1">
+                  <a:txBody>
+                    <a:bodyPr/>
+                    <a:lstStyle/>
+                    <a:p/>
+                  </a:txBody>
+                  <a:tcPr/>
+                </a:tc>
+                <a:tc hMerge="1">
+                  <a:txBody>
+                    <a:bodyPr/>
+                    <a:lstStyle/>
+                    <a:p/>
+                  </a:txBody>
+                  <a:tcPr/>
+                </a:tc>
+                <a:tc hMerge="1">
+                  <a:txBody>
+                    <a:bodyPr/>
+                    <a:lstStyle/>
+                    <a:p/>
+                  </a:txBody>
+                  <a:tcPr/>
+                </a:tc>
+                <a:tc hMerge="1">
+                  <a:txBody>
+                    <a:bodyPr/>
+                    <a:lstStyle/>
+                    <a:p/>
+                  </a:txBody>
+                  <a:tcPr/>
+                </a:tc>
+                <a:tc hMerge="1">
+                  <a:txBody>
+                    <a:bodyPr/>
+                    <a:lstStyle/>
+                    <a:p/>
+                  </a:txBody>
+                  <a:tcPr/>
+                </a:tc>
+                <a:tc hMerge="1">
+                  <a:txBody>
+                    <a:bodyPr/>
+                    <a:lstStyle/>
+                    <a:p/>
+                  </a:txBody>
+                  <a:tcPr/>
+                </a:tc>
+                <a:tc hMerge="1">
+                  <a:txBody>
+                    <a:bodyPr/>
+                    <a:lstStyle/>
+                    <a:p/>
+                  </a:txBody>
+                  <a:tcPr/>
+                </a:tc>
+                <a:tc hMerge="1">
+                  <a:txBody>
+                    <a:bodyPr/>
+                    <a:lstStyle/>
+                    <a:p/>
+                  </a:txBody>
+                  <a:tcPr/>
+                </a:tc>
+              </a:tr>
+              <a:tr h="377163">
+                <a:tc>
+                  <a:txBody>
+                    <a:bodyPr wrap="none"/>
+                    <a:lstStyle/>
+                    <a:p>
+                      <a:pPr algn="l"/>
+                      <a:r>
+                        <a:rPr sz="900" b="0"/>
+                        <a:t> ステージング確認</a:t>
+                      </a:r>
+                    </a:p>
+                  </a:txBody>
+                  <a:tcPr>
+                    <a:solidFill>
+                      <a:srgbClr val="F5F5FA"/>
+                    </a:solidFill>
+                  </a:tcPr>
+                </a:tc>
+                <a:tc>
+                  <a:txBody>
+                    <a:bodyPr/>
+                    <a:lstStyle/>
+                    <a:p/>
+                  </a:txBody>
+                  <a:tcPr/>
+                </a:tc>
+                <a:tc>
+                  <a:txBody>
+                    <a:bodyPr/>
+                    <a:lstStyle/>
+                    <a:p/>
+                  </a:txBody>
+                  <a:tcPr/>
+                </a:tc>
+                <a:tc>
+                  <a:txBody>
+                    <a:bodyPr/>
+                    <a:lstStyle/>
+                    <a:p/>
+                  </a:txBody>
+                  <a:tcPr/>
+                </a:tc>
+                <a:tc>
+                  <a:txBody>
+                    <a:bodyPr/>
+                    <a:lstStyle/>
+                    <a:p/>
+                  </a:txBody>
+                  <a:tcPr/>
+                </a:tc>
+                <a:tc>
+                  <a:txBody>
+                    <a:bodyPr/>
+                    <a:lstStyle/>
+                    <a:p/>
+                  </a:txBody>
+                  <a:tcPr/>
+                </a:tc>
+                <a:tc>
+                  <a:txBody>
+                    <a:bodyPr/>
+                    <a:lstStyle/>
+                    <a:p/>
+                  </a:txBody>
+                  <a:tcPr/>
+                </a:tc>
+                <a:tc>
+                  <a:txBody>
+                    <a:bodyPr/>
+                    <a:lstStyle/>
+                    <a:p/>
+                  </a:txBody>
+                  <a:tcPr/>
+                </a:tc>
+                <a:tc>
+                  <a:txBody>
+                    <a:bodyPr/>
+                    <a:lstStyle/>
+                    <a:p/>
+                  </a:txBody>
+                  <a:tcPr/>
+                </a:tc>
+                <a:tc>
+                  <a:txBody>
+                    <a:bodyPr/>
+                    <a:lstStyle/>
+                    <a:p/>
+                  </a:txBody>
+                  <a:tcPr/>
+                </a:tc>
+              </a:tr>
+              <a:tr h="377163">
+                <a:tc>
+                  <a:txBody>
+                    <a:bodyPr wrap="none"/>
+                    <a:lstStyle/>
+                    <a:p>
+                      <a:pPr algn="l"/>
+                      <a:r>
+                        <a:rPr sz="900" b="0"/>
+                        <a:t> 本番デプロイ</a:t>
+                      </a:r>
+                    </a:p>
+                  </a:txBody>
+                  <a:tcPr>
+                    <a:solidFill>
+                      <a:srgbClr val="F5F5FA"/>
+                    </a:solidFill>
+                  </a:tcPr>
+                </a:tc>
+                <a:tc>
+                  <a:txBody>
+                    <a:bodyPr/>
+                    <a:lstStyle/>
+                    <a:p/>
+                  </a:txBody>
+                  <a:tcPr/>
+                </a:tc>
+                <a:tc>
+                  <a:txBody>
+                    <a:bodyPr/>
+                    <a:lstStyle/>
+                    <a:p/>
+                  </a:txBody>
+                  <a:tcPr/>
+                </a:tc>
+                <a:tc>
+                  <a:txBody>
+                    <a:bodyPr/>
+                    <a:lstStyle/>
+                    <a:p/>
+                  </a:txBody>
+                  <a:tcPr/>
+                </a:tc>
+                <a:tc>
+                  <a:txBody>
+                    <a:bodyPr/>
+                    <a:lstStyle/>
+                    <a:p/>
+                  </a:txBody>
+                  <a:tcPr/>
+                </a:tc>
+                <a:tc>
+                  <a:txBody>
+                    <a:bodyPr/>
+                    <a:lstStyle/>
+                    <a:p/>
+                  </a:txBody>
+                  <a:tcPr/>
+                </a:tc>
+                <a:tc>
+                  <a:txBody>
+                    <a:bodyPr/>
+                    <a:lstStyle/>
+                    <a:p/>
+                  </a:txBody>
+                  <a:tcPr/>
+                </a:tc>
+                <a:tc>
+                  <a:txBody>
+                    <a:bodyPr/>
+                    <a:lstStyle/>
+                    <a:p/>
+                  </a:txBody>
+                  <a:tcPr/>
+                </a:tc>
+                <a:tc>
+                  <a:txBody>
+                    <a:bodyPr/>
+                    <a:lstStyle/>
+                    <a:p/>
+                  </a:txBody>
+                  <a:tcPr/>
+                </a:tc>
+                <a:tc>
+                  <a:txBody>
+                    <a:bodyPr/>
+                    <a:lstStyle/>
+                    <a:p/>
+                  </a:txBody>
+                  <a:tcPr/>
+                </a:tc>
+              </a:tr>
+            </a:tbl>
+          </a:graphicData>
+        </a:graphic>
+      </p:graphicFrame>
+      <p:sp>
+        <p:nvSpPr>
+          <p:cNvPr id="5" name="Right Arrow 4"/>
+          <p:cNvSpPr/>
+          <p:nvPr/>
+        </p:nvSpPr>
+        <p:spPr>
+          <a:xfrm>
+            <a:off x="2396093" y="2411100"/>
+            <a:ext cx="641909" cy="264014"/>
+          </a:xfrm>
+          <a:prstGeom prst="rightArrow">
+            <a:avLst/>
+          </a:prstGeom>
+          <a:solidFill>
+            <a:srgbClr val="AAAAAA"/>
+          </a:solidFill>
+          <a:ln>
+            <a:noFill/>
+          </a:ln>
+        </p:spPr>
+        <p:style>
+          <a:lnRef idx="1">
+            <a:schemeClr val="accent1"/>
+          </a:lnRef>
+          <a:fillRef idx="3">
+            <a:schemeClr val="accent1"/>
+          </a:fillRef>
+          <a:effectRef idx="2">
+            <a:schemeClr val="accent1"/>
+          </a:effectRef>
+          <a:fontRef idx="minor">
+            <a:schemeClr val="lt1"/>
+          </a:fontRef>
+        </p:style>
+        <p:txBody>
+          <a:bodyPr rtlCol="0" anchor="ctr"/>
+          <a:lstStyle/>
+          <a:p/>
+        </p:txBody>
+      </p:sp>
+      <p:sp>
+        <p:nvSpPr>
+          <p:cNvPr id="6" name="Right Arrow 5"/>
+          <p:cNvSpPr/>
+          <p:nvPr/>
+        </p:nvSpPr>
+        <p:spPr>
+          <a:xfrm>
+            <a:off x="3038002" y="2788263"/>
+            <a:ext cx="898672" cy="264014"/>
+          </a:xfrm>
+          <a:prstGeom prst="rightArrow">
+            <a:avLst/>
+          </a:prstGeom>
+          <a:solidFill>
+            <a:srgbClr val="AAAAAA"/>
+          </a:solidFill>
+          <a:ln>
+            <a:noFill/>
+          </a:ln>
+        </p:spPr>
+        <p:style>
+          <a:lnRef idx="1">
+            <a:schemeClr val="accent1"/>
+          </a:lnRef>
+          <a:fillRef idx="3">
+            <a:schemeClr val="accent1"/>
+          </a:fillRef>
+          <a:effectRef idx="2">
+            <a:schemeClr val="accent1"/>
+          </a:effectRef>
+          <a:fontRef idx="minor">
+            <a:schemeClr val="lt1"/>
+          </a:fontRef>
+        </p:style>
+        <p:txBody>
+          <a:bodyPr rtlCol="0" anchor="ctr"/>
+          <a:lstStyle/>
+          <a:p/>
+        </p:txBody>
+      </p:sp>
+      <p:sp>
+        <p:nvSpPr>
+          <p:cNvPr id="7" name="Right Arrow 6"/>
+          <p:cNvSpPr/>
+          <p:nvPr/>
+        </p:nvSpPr>
+        <p:spPr>
+          <a:xfrm>
+            <a:off x="3936674" y="3165426"/>
+            <a:ext cx="641909" cy="264014"/>
+          </a:xfrm>
+          <a:prstGeom prst="rightArrow">
+            <a:avLst/>
+          </a:prstGeom>
+          <a:solidFill>
+            <a:srgbClr val="AAAAAA"/>
+          </a:solidFill>
+          <a:ln>
+            <a:noFill/>
+          </a:ln>
+        </p:spPr>
+        <p:style>
+          <a:lnRef idx="1">
+            <a:schemeClr val="accent1"/>
+          </a:lnRef>
+          <a:fillRef idx="3">
+            <a:schemeClr val="accent1"/>
+          </a:fillRef>
+          <a:effectRef idx="2">
+            <a:schemeClr val="accent1"/>
+          </a:effectRef>
+          <a:fontRef idx="minor">
+            <a:schemeClr val="lt1"/>
+          </a:fontRef>
+        </p:style>
+        <p:txBody>
+          <a:bodyPr rtlCol="0" anchor="ctr"/>
+          <a:lstStyle/>
+          <a:p/>
+        </p:txBody>
+      </p:sp>
+      <p:sp>
+        <p:nvSpPr>
+          <p:cNvPr id="8" name="Right Arrow 7"/>
+          <p:cNvSpPr/>
+          <p:nvPr/>
+        </p:nvSpPr>
+        <p:spPr>
+          <a:xfrm>
+            <a:off x="4578583" y="3919752"/>
+            <a:ext cx="1797345" cy="264014"/>
+          </a:xfrm>
+          <a:prstGeom prst="rightArrow">
+            <a:avLst/>
+          </a:prstGeom>
+          <a:solidFill>
+            <a:srgbClr val="4682B4"/>
+          </a:solidFill>
+          <a:ln>
+            <a:noFill/>
+          </a:ln>
+        </p:spPr>
+        <p:style>
+          <a:lnRef idx="1">
+            <a:schemeClr val="accent1"/>
+          </a:lnRef>
+          <a:fillRef idx="3">
+            <a:schemeClr val="accent1"/>
+          </a:fillRef>
+          <a:effectRef idx="2">
+            <a:schemeClr val="accent1"/>
+          </a:effectRef>
+          <a:fontRef idx="minor">
+            <a:schemeClr val="lt1"/>
+          </a:fontRef>
+        </p:style>
+        <p:txBody>
+          <a:bodyPr rtlCol="0" anchor="ctr"/>
+          <a:lstStyle/>
+          <a:p/>
+        </p:txBody>
+      </p:sp>
+      <p:sp>
+        <p:nvSpPr>
+          <p:cNvPr id="9" name="Right Arrow 8"/>
+          <p:cNvSpPr/>
+          <p:nvPr/>
+        </p:nvSpPr>
+        <p:spPr>
+          <a:xfrm>
+            <a:off x="6375928" y="4296915"/>
+            <a:ext cx="385145" cy="264014"/>
+          </a:xfrm>
+          <a:prstGeom prst="rightArrow">
+            <a:avLst/>
+          </a:prstGeom>
+          <a:solidFill>
+            <a:srgbClr val="DC4646"/>
+          </a:solidFill>
+          <a:ln>
+            <a:noFill/>
+          </a:ln>
+        </p:spPr>
+        <p:style>
+          <a:lnRef idx="1">
+            <a:schemeClr val="accent1"/>
+          </a:lnRef>
+          <a:fillRef idx="3">
+            <a:schemeClr val="accent1"/>
+          </a:fillRef>
+          <a:effectRef idx="2">
+            <a:schemeClr val="accent1"/>
+          </a:effectRef>
+          <a:fontRef idx="minor">
+            <a:schemeClr val="lt1"/>
+          </a:fontRef>
+        </p:style>
+        <p:txBody>
+          <a:bodyPr rtlCol="0" anchor="ctr"/>
+          <a:lstStyle/>
+          <a:p/>
+        </p:txBody>
+      </p:sp>
+      <p:sp>
+        <p:nvSpPr>
+          <p:cNvPr id="10" name="Right Arrow 9"/>
+          <p:cNvSpPr/>
+          <p:nvPr/>
+        </p:nvSpPr>
+        <p:spPr>
+          <a:xfrm>
+            <a:off x="6375928" y="4674078"/>
+            <a:ext cx="898672" cy="264014"/>
+          </a:xfrm>
+          <a:prstGeom prst="rightArrow">
+            <a:avLst/>
+          </a:prstGeom>
+          <a:solidFill>
+            <a:srgbClr val="64B4E6"/>
+          </a:solidFill>
+          <a:ln>
+            <a:noFill/>
+          </a:ln>
+        </p:spPr>
+        <p:style>
+          <a:lnRef idx="1">
+            <a:schemeClr val="accent1"/>
+          </a:lnRef>
+          <a:fillRef idx="3">
+            <a:schemeClr val="accent1"/>
+          </a:fillRef>
+          <a:effectRef idx="2">
+            <a:schemeClr val="accent1"/>
+          </a:effectRef>
+          <a:fontRef idx="minor">
+            <a:schemeClr val="lt1"/>
+          </a:fontRef>
+        </p:style>
+        <p:txBody>
+          <a:bodyPr rtlCol="0" anchor="ctr"/>
+          <a:lstStyle/>
+          <a:p/>
+        </p:txBody>
+      </p:sp>
+      <p:sp>
+        <p:nvSpPr>
+          <p:cNvPr id="11" name="Right Arrow 10"/>
+          <p:cNvSpPr/>
+          <p:nvPr/>
+        </p:nvSpPr>
+        <p:spPr>
+          <a:xfrm>
+            <a:off x="6761073" y="5428404"/>
+            <a:ext cx="256764" cy="264014"/>
+          </a:xfrm>
+          <a:prstGeom prst="rightArrow">
+            <a:avLst/>
+          </a:prstGeom>
+          <a:solidFill>
+            <a:srgbClr val="DC4646"/>
+          </a:solidFill>
+          <a:ln>
+            <a:noFill/>
+          </a:ln>
+        </p:spPr>
+        <p:style>
+          <a:lnRef idx="1">
+            <a:schemeClr val="accent1"/>
+          </a:lnRef>
+          <a:fillRef idx="3">
+            <a:schemeClr val="accent1"/>
+          </a:fillRef>
+          <a:effectRef idx="2">
+            <a:schemeClr val="accent1"/>
+          </a:effectRef>
+          <a:fontRef idx="minor">
+            <a:schemeClr val="lt1"/>
+          </a:fontRef>
+        </p:style>
+        <p:txBody>
+          <a:bodyPr rtlCol="0" anchor="ctr"/>
+          <a:lstStyle/>
+          <a:p/>
+        </p:txBody>
+      </p:sp>
+      <p:sp>
+        <p:nvSpPr>
+          <p:cNvPr id="12" name="Diamond 11"/>
+          <p:cNvSpPr/>
+          <p:nvPr/>
+        </p:nvSpPr>
+        <p:spPr>
+          <a:xfrm>
+            <a:off x="8416982" y="5796138"/>
+            <a:ext cx="282872" cy="282872"/>
+          </a:xfrm>
+          <a:prstGeom prst="diamond">
+            <a:avLst/>
+          </a:prstGeom>
+          <a:solidFill>
+            <a:srgbClr val="DCAA00"/>
+          </a:solidFill>
+          <a:ln>
+            <a:noFill/>
+          </a:ln>
+        </p:spPr>
+        <p:style>
+          <a:lnRef idx="1">
+            <a:schemeClr val="accent1"/>
+          </a:lnRef>
+          <a:fillRef idx="3">
+            <a:schemeClr val="accent1"/>
+          </a:fillRef>
+          <a:effectRef idx="2">
+            <a:schemeClr val="accent1"/>
+          </a:effectRef>
+          <a:fontRef idx="minor">
+            <a:schemeClr val="lt1"/>
+          </a:fontRef>
+        </p:style>
+        <p:txBody>
+          <a:bodyPr rtlCol="0" anchor="ctr"/>
+          <a:lstStyle/>
+          <a:p/>
         </p:txBody>
       </p:sp>
     </p:spTree>

</xml_diff>

<commit_message>
feat: Implement BFS rank layout for state diagrams with cycle support
</commit_message>
<xml_diff>
--- a/demo_full.pptx
+++ b/demo_full.pptx
@@ -12778,7 +12778,7 @@
         </p:nvSpPr>
         <p:spPr>
           <a:xfrm>
-            <a:off x="6162959" y="4270079"/>
+            <a:off x="4382000" y="1861498"/>
             <a:ext cx="380000" cy="380000"/>
           </a:xfrm>
           <a:prstGeom prst="ellipse">
@@ -12819,7 +12819,7 @@
         </p:nvSpPr>
         <p:spPr>
           <a:xfrm>
-            <a:off x="5679518" y="1922085"/>
+            <a:off x="3972000" y="2707339"/>
             <a:ext cx="1200000" cy="500000"/>
           </a:xfrm>
           <a:prstGeom prst="roundRect">
@@ -12872,7 +12872,7 @@
         </p:nvSpPr>
         <p:spPr>
           <a:xfrm>
-            <a:off x="3501144" y="3179892"/>
+            <a:off x="3972000" y="3613181"/>
             <a:ext cx="1200000" cy="500000"/>
           </a:xfrm>
           <a:prstGeom prst="roundRect">
@@ -12925,7 +12925,7 @@
         </p:nvSpPr>
         <p:spPr>
           <a:xfrm>
-            <a:off x="457200" y="3638292"/>
+            <a:off x="7135320" y="4519023"/>
             <a:ext cx="1200000" cy="500000"/>
           </a:xfrm>
           <a:prstGeom prst="roundRect">
@@ -12978,7 +12978,7 @@
         </p:nvSpPr>
         <p:spPr>
           <a:xfrm>
-            <a:off x="7152447" y="3496469"/>
+            <a:off x="808679" y="4519023"/>
             <a:ext cx="1200000" cy="500000"/>
           </a:xfrm>
           <a:prstGeom prst="roundRect">
@@ -13031,7 +13031,7 @@
         </p:nvSpPr>
         <p:spPr>
           <a:xfrm>
-            <a:off x="1663730" y="5257268"/>
+            <a:off x="4347000" y="5449864"/>
             <a:ext cx="450000" cy="450000"/>
           </a:xfrm>
           <a:prstGeom prst="ellipse">
@@ -13072,7 +13072,7 @@
         </p:nvSpPr>
         <p:spPr>
           <a:xfrm>
-            <a:off x="1763730" y="5357268"/>
+            <a:off x="4447000" y="5549864"/>
             <a:ext cx="250000" cy="250000"/>
           </a:xfrm>
           <a:prstGeom prst="ellipse">
@@ -13109,15 +13109,15 @@
         <p:nvCxnSpPr>
           <p:cNvPr id="11" name="Connector 10"/>
           <p:cNvCxnSpPr>
-            <a:stCxn id="4" idx="0"/>
-            <a:endCxn id="5" idx="2"/>
+            <a:stCxn id="4" idx="2"/>
+            <a:endCxn id="5" idx="0"/>
           </p:cNvCxnSpPr>
           <p:nvPr/>
         </p:nvCxnSpPr>
         <p:spPr>
-          <a:xfrm flipH="1" flipV="1">
-            <a:off x="6279518" y="2422085"/>
-            <a:ext cx="73441" cy="1847994"/>
+          <a:xfrm>
+            <a:off x="4572000" y="2241498"/>
+            <a:ext cx="0" cy="465841"/>
           </a:xfrm>
           <a:prstGeom prst="curvedConnector3">
             <a:avLst/>
@@ -13145,15 +13145,15 @@
         <p:nvCxnSpPr>
           <p:cNvPr id="12" name="Connector 11"/>
           <p:cNvCxnSpPr>
-            <a:stCxn id="5" idx="3"/>
-            <a:endCxn id="6" idx="1"/>
+            <a:stCxn id="5" idx="2"/>
+            <a:endCxn id="6" idx="0"/>
           </p:cNvCxnSpPr>
           <p:nvPr/>
         </p:nvCxnSpPr>
         <p:spPr>
-          <a:xfrm flipH="1">
-            <a:off x="3501144" y="2172085"/>
-            <a:ext cx="3378374" cy="1257807"/>
+          <a:xfrm>
+            <a:off x="4572000" y="3207339"/>
+            <a:ext cx="0" cy="405842"/>
           </a:xfrm>
           <a:prstGeom prst="curvedConnector3">
             <a:avLst/>
@@ -13185,7 +13185,7 @@
         </p:nvSpPr>
         <p:spPr>
           <a:xfrm>
-            <a:off x="4690331" y="2650988"/>
+            <a:off x="4072000" y="3260260"/>
             <a:ext cx="1000000" cy="300000"/>
           </a:xfrm>
           <a:prstGeom prst="rect">
@@ -13215,15 +13215,15 @@
         <p:nvCxnSpPr>
           <p:cNvPr id="14" name="Connector 13"/>
           <p:cNvCxnSpPr>
-            <a:stCxn id="6" idx="3"/>
-            <a:endCxn id="7" idx="1"/>
+            <a:stCxn id="6" idx="1"/>
+            <a:endCxn id="7" idx="3"/>
           </p:cNvCxnSpPr>
           <p:nvPr/>
         </p:nvCxnSpPr>
         <p:spPr>
-          <a:xfrm flipH="1">
-            <a:off x="457200" y="3429892"/>
-            <a:ext cx="4243944" cy="458400"/>
+          <a:xfrm>
+            <a:off x="3972000" y="3863181"/>
+            <a:ext cx="4363320" cy="905842"/>
           </a:xfrm>
           <a:prstGeom prst="curvedConnector3">
             <a:avLst/>
@@ -13255,7 +13255,7 @@
         </p:nvSpPr>
         <p:spPr>
           <a:xfrm>
-            <a:off x="2079172" y="3509092"/>
+            <a:off x="5653660" y="4166102"/>
             <a:ext cx="1000000" cy="300000"/>
           </a:xfrm>
           <a:prstGeom prst="rect">
@@ -13285,15 +13285,15 @@
         <p:nvCxnSpPr>
           <p:cNvPr id="16" name="Connector 15"/>
           <p:cNvCxnSpPr>
-            <a:stCxn id="6" idx="1"/>
-            <a:endCxn id="8" idx="3"/>
+            <a:stCxn id="6" idx="3"/>
+            <a:endCxn id="8" idx="1"/>
           </p:cNvCxnSpPr>
           <p:nvPr/>
         </p:nvCxnSpPr>
         <p:spPr>
-          <a:xfrm>
-            <a:off x="3501144" y="3429892"/>
-            <a:ext cx="4851303" cy="316577"/>
+          <a:xfrm flipH="1">
+            <a:off x="808679" y="3863181"/>
+            <a:ext cx="4363321" cy="905842"/>
           </a:xfrm>
           <a:prstGeom prst="curvedConnector3">
             <a:avLst/>
@@ -13325,7 +13325,7 @@
         </p:nvSpPr>
         <p:spPr>
           <a:xfrm>
-            <a:off x="5426795" y="3438180"/>
+            <a:off x="2490339" y="4166102"/>
             <a:ext cx="1000000" cy="300000"/>
           </a:xfrm>
           <a:prstGeom prst="rect">
@@ -13355,15 +13355,15 @@
         <p:nvCxnSpPr>
           <p:cNvPr id="18" name="Connector 17"/>
           <p:cNvCxnSpPr>
-            <a:stCxn id="8" idx="0"/>
-            <a:endCxn id="5" idx="2"/>
+            <a:stCxn id="8" idx="1"/>
+            <a:endCxn id="5" idx="3"/>
           </p:cNvCxnSpPr>
           <p:nvPr/>
         </p:nvCxnSpPr>
         <p:spPr>
-          <a:xfrm flipH="1" flipV="1">
-            <a:off x="6279518" y="2422085"/>
-            <a:ext cx="1472929" cy="1074384"/>
+          <a:xfrm flipV="1">
+            <a:off x="808679" y="2957339"/>
+            <a:ext cx="4363321" cy="1811684"/>
           </a:xfrm>
           <a:prstGeom prst="curvedConnector3">
             <a:avLst/>
@@ -13395,7 +13395,7 @@
         </p:nvSpPr>
         <p:spPr>
           <a:xfrm>
-            <a:off x="6515982" y="2809277"/>
+            <a:off x="2490339" y="3713181"/>
             <a:ext cx="1000000" cy="300000"/>
           </a:xfrm>
           <a:prstGeom prst="rect">
@@ -13425,15 +13425,15 @@
         <p:nvCxnSpPr>
           <p:cNvPr id="20" name="Connector 19"/>
           <p:cNvCxnSpPr>
-            <a:stCxn id="7" idx="2"/>
-            <a:endCxn id="9" idx="0"/>
+            <a:stCxn id="7" idx="3"/>
+            <a:endCxn id="9" idx="1"/>
           </p:cNvCxnSpPr>
           <p:nvPr/>
         </p:nvCxnSpPr>
         <p:spPr>
-          <a:xfrm>
-            <a:off x="1057200" y="4138292"/>
-            <a:ext cx="831530" cy="1118976"/>
+          <a:xfrm flipH="1">
+            <a:off x="4347000" y="4769023"/>
+            <a:ext cx="3988320" cy="905841"/>
           </a:xfrm>
           <a:prstGeom prst="curvedConnector3">
             <a:avLst/>
@@ -13521,7 +13521,7 @@
         </p:nvSpPr>
         <p:spPr>
           <a:xfrm>
-            <a:off x="2272000" y="2188180"/>
+            <a:off x="2272000" y="3538181"/>
             <a:ext cx="4600000" cy="2420000"/>
           </a:xfrm>
           <a:prstGeom prst="roundRect">
@@ -13565,84 +13565,7 @@
         </p:nvSpPr>
         <p:spPr>
           <a:xfrm>
-            <a:off x="2872000" y="2653181"/>
-            <a:ext cx="3400000" cy="2420000"/>
-          </a:xfrm>
-          <a:prstGeom prst="roundRect">
-            <a:avLst/>
-          </a:prstGeom>
-          <a:solidFill>
-            <a:srgbClr val="EEF4FF"/>
-          </a:solidFill>
-          <a:ln>
-            <a:solidFill>
-              <a:srgbClr val="4664AA"/>
-            </a:solidFill>
-          </a:ln>
-        </p:spPr>
-        <p:style>
-          <a:lnRef idx="1">
-            <a:schemeClr val="accent1"/>
-          </a:lnRef>
-          <a:fillRef idx="3">
-            <a:schemeClr val="accent1"/>
-          </a:fillRef>
-          <a:effectRef idx="2">
-            <a:schemeClr val="accent1"/>
-          </a:effectRef>
-          <a:fontRef idx="minor">
-            <a:schemeClr val="lt1"/>
-          </a:fontRef>
-        </p:style>
-        <p:txBody>
-          <a:bodyPr rtlCol="0" anchor="ctr"/>
-          <a:lstStyle/>
-          <a:p/>
-        </p:txBody>
-      </p:sp>
-      <p:sp>
-        <p:nvSpPr>
-          <p:cNvPr id="6" name="TextBox 5"/>
-          <p:cNvSpPr txBox="1"/>
-          <p:nvPr/>
-        </p:nvSpPr>
-        <p:spPr>
-          <a:xfrm>
-            <a:off x="2872000" y="2653181"/>
-            <a:ext cx="3400000" cy="420000"/>
-          </a:xfrm>
-          <a:prstGeom prst="rect">
-            <a:avLst/>
-          </a:prstGeom>
-          <a:noFill/>
-        </p:spPr>
-        <p:txBody>
-          <a:bodyPr wrap="none">
-            <a:spAutoFit/>
-          </a:bodyPr>
-          <a:lstStyle/>
-          <a:p>
-            <a:pPr algn="ctr"/>
-            <a:r>
-              <a:rPr sz="1100" b="1">
-                <a:solidFill>
-                  <a:srgbClr val="4664AA"/>
-                </a:solidFill>
-              </a:rPr>
-              <a:t>Active</a:t>
-            </a:r>
-          </a:p>
-        </p:txBody>
-      </p:sp>
-      <p:sp>
-        <p:nvSpPr>
-          <p:cNvPr id="7" name="Rounded Rectangle 6"/>
-          <p:cNvSpPr/>
-          <p:nvPr/>
-        </p:nvSpPr>
-        <p:spPr>
-          <a:xfrm>
-            <a:off x="2272000" y="3538181"/>
+            <a:off x="2272000" y="2188180"/>
             <a:ext cx="4600000" cy="2420000"/>
           </a:xfrm>
           <a:prstGeom prst="roundRect">
@@ -13680,6 +13603,83 @@
       </p:sp>
       <p:sp>
         <p:nvSpPr>
+          <p:cNvPr id="6" name="Rounded Rectangle 5"/>
+          <p:cNvSpPr/>
+          <p:nvPr/>
+        </p:nvSpPr>
+        <p:spPr>
+          <a:xfrm>
+            <a:off x="2872000" y="2653181"/>
+            <a:ext cx="3400000" cy="2420000"/>
+          </a:xfrm>
+          <a:prstGeom prst="roundRect">
+            <a:avLst/>
+          </a:prstGeom>
+          <a:solidFill>
+            <a:srgbClr val="EEF4FF"/>
+          </a:solidFill>
+          <a:ln>
+            <a:solidFill>
+              <a:srgbClr val="4664AA"/>
+            </a:solidFill>
+          </a:ln>
+        </p:spPr>
+        <p:style>
+          <a:lnRef idx="1">
+            <a:schemeClr val="accent1"/>
+          </a:lnRef>
+          <a:fillRef idx="3">
+            <a:schemeClr val="accent1"/>
+          </a:fillRef>
+          <a:effectRef idx="2">
+            <a:schemeClr val="accent1"/>
+          </a:effectRef>
+          <a:fontRef idx="minor">
+            <a:schemeClr val="lt1"/>
+          </a:fontRef>
+        </p:style>
+        <p:txBody>
+          <a:bodyPr rtlCol="0" anchor="ctr"/>
+          <a:lstStyle/>
+          <a:p/>
+        </p:txBody>
+      </p:sp>
+      <p:sp>
+        <p:nvSpPr>
+          <p:cNvPr id="7" name="TextBox 6"/>
+          <p:cNvSpPr txBox="1"/>
+          <p:nvPr/>
+        </p:nvSpPr>
+        <p:spPr>
+          <a:xfrm>
+            <a:off x="2872000" y="2653181"/>
+            <a:ext cx="3400000" cy="420000"/>
+          </a:xfrm>
+          <a:prstGeom prst="rect">
+            <a:avLst/>
+          </a:prstGeom>
+          <a:noFill/>
+        </p:spPr>
+        <p:txBody>
+          <a:bodyPr wrap="none">
+            <a:spAutoFit/>
+          </a:bodyPr>
+          <a:lstStyle/>
+          <a:p>
+            <a:pPr algn="ctr"/>
+            <a:r>
+              <a:rPr sz="1100" b="1">
+                <a:solidFill>
+                  <a:srgbClr val="4664AA"/>
+                </a:solidFill>
+              </a:rPr>
+              <a:t>Active</a:t>
+            </a:r>
+          </a:p>
+        </p:txBody>
+      </p:sp>
+      <p:sp>
+        <p:nvSpPr>
           <p:cNvPr id="8" name="Oval 7"/>
           <p:cNvSpPr/>
           <p:nvPr/>
@@ -13809,7 +13809,7 @@
         </p:nvSpPr>
         <p:spPr>
           <a:xfrm>
-            <a:off x="4821071" y="4168180"/>
+            <a:off x="2761999" y="3418180"/>
             <a:ext cx="380000" cy="380000"/>
           </a:xfrm>
           <a:prstGeom prst="ellipse">
@@ -13850,7 +13850,7 @@
         </p:nvSpPr>
         <p:spPr>
           <a:xfrm>
-            <a:off x="4549899" y="3157706"/>
+            <a:off x="3972000" y="3358180"/>
             <a:ext cx="1200000" cy="500000"/>
           </a:xfrm>
           <a:prstGeom prst="roundRect">
@@ -13903,7 +13903,7 @@
         </p:nvSpPr>
         <p:spPr>
           <a:xfrm>
-            <a:off x="2955029" y="2808653"/>
+            <a:off x="5592000" y="3358180"/>
             <a:ext cx="1200000" cy="500000"/>
           </a:xfrm>
           <a:prstGeom prst="roundRect">
@@ -13956,7 +13956,7 @@
         </p:nvSpPr>
         <p:spPr>
           <a:xfrm>
-            <a:off x="4821071" y="5518181"/>
+            <a:off x="2761999" y="4768181"/>
             <a:ext cx="380000" cy="380000"/>
           </a:xfrm>
           <a:prstGeom prst="ellipse">
@@ -13997,7 +13997,7 @@
         </p:nvSpPr>
         <p:spPr>
           <a:xfrm>
-            <a:off x="4549899" y="4507707"/>
+            <a:off x="3972000" y="4708181"/>
             <a:ext cx="1200000" cy="500000"/>
           </a:xfrm>
           <a:prstGeom prst="roundRect">
@@ -14050,7 +14050,7 @@
         </p:nvSpPr>
         <p:spPr>
           <a:xfrm>
-            <a:off x="2955029" y="4158654"/>
+            <a:off x="5592000" y="4708181"/>
             <a:ext cx="1200000" cy="500000"/>
           </a:xfrm>
           <a:prstGeom prst="roundRect">
@@ -14152,7 +14152,7 @@
           <p:cNvPr id="18" name="Connector 17"/>
           <p:cNvCxnSpPr>
             <a:stCxn id="8" idx="1"/>
-            <a:endCxn id="5" idx="3"/>
+            <a:endCxn id="6" idx="3"/>
           </p:cNvCxnSpPr>
           <p:nvPr/>
         </p:nvCxnSpPr>
@@ -14187,15 +14187,15 @@
         <p:nvCxnSpPr>
           <p:cNvPr id="19" name="Connector 18"/>
           <p:cNvCxnSpPr>
-            <a:stCxn id="11" idx="0"/>
-            <a:endCxn id="12" idx="2"/>
+            <a:stCxn id="11" idx="1"/>
+            <a:endCxn id="12" idx="3"/>
           </p:cNvCxnSpPr>
           <p:nvPr/>
         </p:nvCxnSpPr>
         <p:spPr>
-          <a:xfrm flipV="1">
-            <a:off x="5011071" y="3657706"/>
-            <a:ext cx="138828" cy="510474"/>
+          <a:xfrm>
+            <a:off x="2761999" y="3608180"/>
+            <a:ext cx="2410001" cy="0"/>
           </a:xfrm>
           <a:prstGeom prst="curvedConnector3">
             <a:avLst/>
@@ -14223,15 +14223,15 @@
         <p:nvCxnSpPr>
           <p:cNvPr id="20" name="Connector 19"/>
           <p:cNvCxnSpPr>
-            <a:stCxn id="12" idx="3"/>
-            <a:endCxn id="13" idx="1"/>
+            <a:stCxn id="12" idx="1"/>
+            <a:endCxn id="13" idx="3"/>
           </p:cNvCxnSpPr>
           <p:nvPr/>
         </p:nvCxnSpPr>
         <p:spPr>
-          <a:xfrm flipH="1" flipV="1">
-            <a:off x="2955029" y="3058653"/>
-            <a:ext cx="2794870" cy="349053"/>
+          <a:xfrm>
+            <a:off x="3972000" y="3608180"/>
+            <a:ext cx="2820000" cy="0"/>
           </a:xfrm>
           <a:prstGeom prst="curvedConnector3">
             <a:avLst/>
@@ -14263,7 +14263,7 @@
         </p:nvSpPr>
         <p:spPr>
           <a:xfrm>
-            <a:off x="3852464" y="3083179"/>
+            <a:off x="4882000" y="3458180"/>
             <a:ext cx="1000000" cy="300000"/>
           </a:xfrm>
           <a:prstGeom prst="rect">
@@ -14293,15 +14293,15 @@
         <p:nvCxnSpPr>
           <p:cNvPr id="22" name="Connector 21"/>
           <p:cNvCxnSpPr>
-            <a:stCxn id="13" idx="1"/>
-            <a:endCxn id="12" idx="3"/>
+            <a:stCxn id="13" idx="3"/>
+            <a:endCxn id="12" idx="1"/>
           </p:cNvCxnSpPr>
           <p:nvPr/>
         </p:nvCxnSpPr>
         <p:spPr>
-          <a:xfrm>
-            <a:off x="2955029" y="3058653"/>
-            <a:ext cx="2794870" cy="349053"/>
+          <a:xfrm flipH="1">
+            <a:off x="3972000" y="3608180"/>
+            <a:ext cx="2820000" cy="0"/>
           </a:xfrm>
           <a:prstGeom prst="curvedConnector3">
             <a:avLst/>
@@ -14333,7 +14333,7 @@
         </p:nvSpPr>
         <p:spPr>
           <a:xfrm>
-            <a:off x="3852464" y="3083179"/>
+            <a:off x="4882000" y="3458180"/>
             <a:ext cx="1000000" cy="300000"/>
           </a:xfrm>
           <a:prstGeom prst="rect">
@@ -14363,15 +14363,15 @@
         <p:nvCxnSpPr>
           <p:cNvPr id="24" name="Connector 23"/>
           <p:cNvCxnSpPr>
-            <a:stCxn id="14" idx="0"/>
-            <a:endCxn id="15" idx="2"/>
+            <a:stCxn id="14" idx="1"/>
+            <a:endCxn id="15" idx="3"/>
           </p:cNvCxnSpPr>
           <p:nvPr/>
         </p:nvCxnSpPr>
         <p:spPr>
-          <a:xfrm flipV="1">
-            <a:off x="5011071" y="5007707"/>
-            <a:ext cx="138828" cy="510474"/>
+          <a:xfrm>
+            <a:off x="2761999" y="4958181"/>
+            <a:ext cx="2410001" cy="0"/>
           </a:xfrm>
           <a:prstGeom prst="curvedConnector3">
             <a:avLst/>
@@ -14399,15 +14399,15 @@
         <p:nvCxnSpPr>
           <p:cNvPr id="25" name="Connector 24"/>
           <p:cNvCxnSpPr>
-            <a:stCxn id="15" idx="3"/>
-            <a:endCxn id="16" idx="1"/>
+            <a:stCxn id="15" idx="1"/>
+            <a:endCxn id="16" idx="3"/>
           </p:cNvCxnSpPr>
           <p:nvPr/>
         </p:nvCxnSpPr>
         <p:spPr>
-          <a:xfrm flipH="1" flipV="1">
-            <a:off x="2955029" y="4408654"/>
-            <a:ext cx="2794870" cy="349053"/>
+          <a:xfrm>
+            <a:off x="3972000" y="4958181"/>
+            <a:ext cx="2820000" cy="0"/>
           </a:xfrm>
           <a:prstGeom prst="curvedConnector3">
             <a:avLst/>
@@ -14439,7 +14439,7 @@
         </p:nvSpPr>
         <p:spPr>
           <a:xfrm>
-            <a:off x="3852464" y="4433180"/>
+            <a:off x="4882000" y="4808181"/>
             <a:ext cx="1000000" cy="300000"/>
           </a:xfrm>
           <a:prstGeom prst="rect">
@@ -14469,15 +14469,15 @@
         <p:nvCxnSpPr>
           <p:cNvPr id="27" name="Connector 26"/>
           <p:cNvCxnSpPr>
-            <a:stCxn id="16" idx="1"/>
-            <a:endCxn id="15" idx="3"/>
+            <a:stCxn id="16" idx="3"/>
+            <a:endCxn id="15" idx="1"/>
           </p:cNvCxnSpPr>
           <p:nvPr/>
         </p:nvCxnSpPr>
         <p:spPr>
-          <a:xfrm>
-            <a:off x="2955029" y="4408654"/>
-            <a:ext cx="2794870" cy="349053"/>
+          <a:xfrm flipH="1">
+            <a:off x="3972000" y="4958181"/>
+            <a:ext cx="2820000" cy="0"/>
           </a:xfrm>
           <a:prstGeom prst="curvedConnector3">
             <a:avLst/>
@@ -14509,7 +14509,7 @@
         </p:nvSpPr>
         <p:spPr>
           <a:xfrm>
-            <a:off x="3852464" y="4433180"/>
+            <a:off x="4882000" y="4808181"/>
             <a:ext cx="1000000" cy="300000"/>
           </a:xfrm>
           <a:prstGeom prst="rect">
@@ -14539,7 +14539,7 @@
         <p:nvCxnSpPr>
           <p:cNvPr id="29" name="Connector 28"/>
           <p:cNvCxnSpPr>
-            <a:stCxn id="5" idx="1"/>
+            <a:stCxn id="6" idx="1"/>
             <a:endCxn id="9" idx="3"/>
           </p:cNvCxnSpPr>
           <p:nvPr/>
@@ -14994,7 +14994,7 @@
         </p:nvSpPr>
         <p:spPr>
           <a:xfrm>
-            <a:off x="2772000" y="5467697"/>
+            <a:off x="3972000" y="4054022"/>
             <a:ext cx="1200000" cy="500000"/>
           </a:xfrm>
           <a:prstGeom prst="roundRect">
@@ -15047,7 +15047,7 @@
         </p:nvSpPr>
         <p:spPr>
           <a:xfrm>
-            <a:off x="5172000" y="3990348"/>
+            <a:off x="3972000" y="5404023"/>
             <a:ext cx="1200000" cy="500000"/>
           </a:xfrm>
           <a:prstGeom prst="roundRect">
@@ -15272,15 +15272,15 @@
         <p:nvCxnSpPr>
           <p:cNvPr id="19" name="Connector 18"/>
           <p:cNvCxnSpPr>
-            <a:stCxn id="12" idx="1"/>
-            <a:endCxn id="13" idx="3"/>
+            <a:stCxn id="12" idx="2"/>
+            <a:endCxn id="13" idx="0"/>
           </p:cNvCxnSpPr>
           <p:nvPr/>
         </p:nvCxnSpPr>
         <p:spPr>
-          <a:xfrm flipV="1">
-            <a:off x="2772000" y="4240348"/>
-            <a:ext cx="3600000" cy="1477349"/>
+          <a:xfrm>
+            <a:off x="4572000" y="4554022"/>
+            <a:ext cx="0" cy="850001"/>
           </a:xfrm>
           <a:prstGeom prst="curvedConnector3">
             <a:avLst/>
@@ -15342,15 +15342,15 @@
         <p:nvCxnSpPr>
           <p:cNvPr id="21" name="Connector 20"/>
           <p:cNvCxnSpPr>
-            <a:stCxn id="13" idx="3"/>
-            <a:endCxn id="12" idx="1"/>
+            <a:stCxn id="13" idx="0"/>
+            <a:endCxn id="12" idx="2"/>
           </p:cNvCxnSpPr>
           <p:nvPr/>
         </p:nvCxnSpPr>
         <p:spPr>
-          <a:xfrm flipH="1">
-            <a:off x="2772000" y="4240348"/>
-            <a:ext cx="3600000" cy="1477349"/>
+          <a:xfrm flipV="1">
+            <a:off x="4572000" y="4554022"/>
+            <a:ext cx="0" cy="850001"/>
           </a:xfrm>
           <a:prstGeom prst="curvedConnector3">
             <a:avLst/>

</xml_diff>

<commit_message>
Add JourneyRenderer and JourneyParser for user journey diagrams
- Implemented JourneyRenderer to draw user journey diagrams in PPTX format.
- Created JourneyParser to parse Mermaid journey syntax into structured data.
- Added unit tests for JourneyParser and JourneyRenderer to ensure correct functionality.
- Updated MermaidRenderer to support rendering journey diagrams.
</commit_message>
<xml_diff>
--- a/demo_full.pptx
+++ b/demo_full.pptx
@@ -13923,7 +13923,7 @@
         </p:nvSpPr>
         <p:spPr>
           <a:xfrm>
-            <a:off x="2272000" y="3538181"/>
+            <a:off x="2272000" y="2188180"/>
             <a:ext cx="4600000" cy="2420000"/>
           </a:xfrm>
           <a:prstGeom prst="roundRect">
@@ -13967,7 +13967,84 @@
         </p:nvSpPr>
         <p:spPr>
           <a:xfrm>
-            <a:off x="2272000" y="2188180"/>
+            <a:off x="2872000" y="2653181"/>
+            <a:ext cx="3400000" cy="2420000"/>
+          </a:xfrm>
+          <a:prstGeom prst="roundRect">
+            <a:avLst/>
+          </a:prstGeom>
+          <a:solidFill>
+            <a:srgbClr val="EEF4FF"/>
+          </a:solidFill>
+          <a:ln>
+            <a:solidFill>
+              <a:srgbClr val="4664AA"/>
+            </a:solidFill>
+          </a:ln>
+        </p:spPr>
+        <p:style>
+          <a:lnRef idx="1">
+            <a:schemeClr val="accent1"/>
+          </a:lnRef>
+          <a:fillRef idx="3">
+            <a:schemeClr val="accent1"/>
+          </a:fillRef>
+          <a:effectRef idx="2">
+            <a:schemeClr val="accent1"/>
+          </a:effectRef>
+          <a:fontRef idx="minor">
+            <a:schemeClr val="lt1"/>
+          </a:fontRef>
+        </p:style>
+        <p:txBody>
+          <a:bodyPr rtlCol="0" anchor="ctr"/>
+          <a:lstStyle/>
+          <a:p/>
+        </p:txBody>
+      </p:sp>
+      <p:sp>
+        <p:nvSpPr>
+          <p:cNvPr id="6" name="TextBox 5"/>
+          <p:cNvSpPr txBox="1"/>
+          <p:nvPr/>
+        </p:nvSpPr>
+        <p:spPr>
+          <a:xfrm>
+            <a:off x="2872000" y="2653181"/>
+            <a:ext cx="3400000" cy="420000"/>
+          </a:xfrm>
+          <a:prstGeom prst="rect">
+            <a:avLst/>
+          </a:prstGeom>
+          <a:noFill/>
+        </p:spPr>
+        <p:txBody>
+          <a:bodyPr wrap="none">
+            <a:spAutoFit/>
+          </a:bodyPr>
+          <a:lstStyle/>
+          <a:p>
+            <a:pPr algn="ctr"/>
+            <a:r>
+              <a:rPr sz="1100" b="1">
+                <a:solidFill>
+                  <a:srgbClr val="4664AA"/>
+                </a:solidFill>
+              </a:rPr>
+              <a:t>Active</a:t>
+            </a:r>
+          </a:p>
+        </p:txBody>
+      </p:sp>
+      <p:sp>
+        <p:nvSpPr>
+          <p:cNvPr id="7" name="Rounded Rectangle 6"/>
+          <p:cNvSpPr/>
+          <p:nvPr/>
+        </p:nvSpPr>
+        <p:spPr>
+          <a:xfrm>
+            <a:off x="2272000" y="3538181"/>
             <a:ext cx="4600000" cy="2420000"/>
           </a:xfrm>
           <a:prstGeom prst="roundRect">
@@ -14005,83 +14082,6 @@
       </p:sp>
       <p:sp>
         <p:nvSpPr>
-          <p:cNvPr id="6" name="Rounded Rectangle 5"/>
-          <p:cNvSpPr/>
-          <p:nvPr/>
-        </p:nvSpPr>
-        <p:spPr>
-          <a:xfrm>
-            <a:off x="2872000" y="2653181"/>
-            <a:ext cx="3400000" cy="2420000"/>
-          </a:xfrm>
-          <a:prstGeom prst="roundRect">
-            <a:avLst/>
-          </a:prstGeom>
-          <a:solidFill>
-            <a:srgbClr val="EEF4FF"/>
-          </a:solidFill>
-          <a:ln>
-            <a:solidFill>
-              <a:srgbClr val="4664AA"/>
-            </a:solidFill>
-          </a:ln>
-        </p:spPr>
-        <p:style>
-          <a:lnRef idx="1">
-            <a:schemeClr val="accent1"/>
-          </a:lnRef>
-          <a:fillRef idx="3">
-            <a:schemeClr val="accent1"/>
-          </a:fillRef>
-          <a:effectRef idx="2">
-            <a:schemeClr val="accent1"/>
-          </a:effectRef>
-          <a:fontRef idx="minor">
-            <a:schemeClr val="lt1"/>
-          </a:fontRef>
-        </p:style>
-        <p:txBody>
-          <a:bodyPr rtlCol="0" anchor="ctr"/>
-          <a:lstStyle/>
-          <a:p/>
-        </p:txBody>
-      </p:sp>
-      <p:sp>
-        <p:nvSpPr>
-          <p:cNvPr id="7" name="TextBox 6"/>
-          <p:cNvSpPr txBox="1"/>
-          <p:nvPr/>
-        </p:nvSpPr>
-        <p:spPr>
-          <a:xfrm>
-            <a:off x="2872000" y="2653181"/>
-            <a:ext cx="3400000" cy="420000"/>
-          </a:xfrm>
-          <a:prstGeom prst="rect">
-            <a:avLst/>
-          </a:prstGeom>
-          <a:noFill/>
-        </p:spPr>
-        <p:txBody>
-          <a:bodyPr wrap="none">
-            <a:spAutoFit/>
-          </a:bodyPr>
-          <a:lstStyle/>
-          <a:p>
-            <a:pPr algn="ctr"/>
-            <a:r>
-              <a:rPr sz="1100" b="1">
-                <a:solidFill>
-                  <a:srgbClr val="4664AA"/>
-                </a:solidFill>
-              </a:rPr>
-              <a:t>Active</a:t>
-            </a:r>
-          </a:p>
-        </p:txBody>
-      </p:sp>
-      <p:sp>
-        <p:nvSpPr>
           <p:cNvPr id="8" name="Oval 7"/>
           <p:cNvSpPr/>
           <p:nvPr/>
@@ -14342,7 +14342,7 @@
           <p:cNvPr id="18" name="Connector 17"/>
           <p:cNvCxnSpPr>
             <a:stCxn id="8" idx="3"/>
-            <a:endCxn id="6" idx="1"/>
+            <a:endCxn id="5" idx="1"/>
           </p:cNvCxnSpPr>
           <p:nvPr/>
         </p:nvCxnSpPr>
@@ -14593,7 +14593,7 @@
         <p:nvCxnSpPr>
           <p:cNvPr id="29" name="Connector 28"/>
           <p:cNvCxnSpPr>
-            <a:stCxn id="6" idx="3"/>
+            <a:stCxn id="5" idx="3"/>
             <a:endCxn id="9" idx="1"/>
           </p:cNvCxnSpPr>
           <p:nvPr/>
@@ -17763,7 +17763,86 @@
         <p:spPr>
           <a:xfrm>
             <a:off x="457200" y="1600200"/>
-            <a:ext cx="8229600" cy="4525963"/>
+            <a:ext cx="8229600" cy="543115"/>
+          </a:xfrm>
+          <a:prstGeom prst="rect">
+            <a:avLst/>
+          </a:prstGeom>
+          <a:noFill/>
+        </p:spPr>
+        <p:txBody>
+          <a:bodyPr wrap="none">
+            <a:spAutoFit/>
+          </a:bodyPr>
+          <a:lstStyle/>
+          <a:p>
+            <a:pPr algn="ctr"/>
+            <a:r>
+              <a:rPr sz="2000" b="1">
+                <a:solidFill>
+                  <a:srgbClr val="1E1E3C"/>
+                </a:solidFill>
+              </a:rPr>
+              <a:t>オンラインショッピング体験</a:t>
+            </a:r>
+          </a:p>
+        </p:txBody>
+      </p:sp>
+      <p:sp>
+        <p:nvSpPr>
+          <p:cNvPr id="5" name="Oval 4"/>
+          <p:cNvSpPr/>
+          <p:nvPr/>
+        </p:nvSpPr>
+        <p:spPr>
+          <a:xfrm>
+            <a:off x="537200" y="2263315"/>
+            <a:ext cx="160000" cy="160000"/>
+          </a:xfrm>
+          <a:prstGeom prst="ellipse">
+            <a:avLst/>
+          </a:prstGeom>
+          <a:solidFill>
+            <a:srgbClr val="8FBC8F"/>
+          </a:solidFill>
+          <a:ln w="9525">
+            <a:solidFill>
+              <a:srgbClr val="505050"/>
+            </a:solidFill>
+          </a:ln>
+        </p:spPr>
+        <p:style>
+          <a:lnRef idx="1">
+            <a:schemeClr val="accent1"/>
+          </a:lnRef>
+          <a:fillRef idx="3">
+            <a:schemeClr val="accent1"/>
+          </a:fillRef>
+          <a:effectRef idx="2">
+            <a:schemeClr val="accent1"/>
+          </a:effectRef>
+          <a:fontRef idx="minor">
+            <a:schemeClr val="lt1"/>
+          </a:fontRef>
+        </p:style>
+        <p:txBody>
+          <a:bodyPr rtlCol="0" anchor="ctr"/>
+          <a:lstStyle/>
+          <a:p>
+            <a:pPr algn="ctr"/>
+          </a:p>
+        </p:txBody>
+      </p:sp>
+      <p:sp>
+        <p:nvSpPr>
+          <p:cNvPr id="6" name="TextBox 5"/>
+          <p:cNvSpPr txBox="1"/>
+          <p:nvPr/>
+        </p:nvSpPr>
+        <p:spPr>
+          <a:xfrm>
+            <a:off x="757200" y="2143315"/>
+            <a:ext cx="720000" cy="400000"/>
           </a:xfrm>
           <a:prstGeom prst="rect">
             <a:avLst/>
@@ -17777,20 +17856,997 @@
           <a:lstStyle/>
           <a:p>
             <a:r>
-              <a:rPr sz="1000">
-                <a:latin typeface="Courier New"/>
+              <a:rPr sz="1100">
+                <a:solidFill>
+                  <a:srgbClr val="28283C"/>
+                </a:solidFill>
               </a:rPr>
-              <a:t>journey
-    title オンラインショッピング体験
-    section 商品探し
-        サイト訪問    : 5: ユーザー
-        検索実行      : 3: ユーザー
-        商品選択      : 4: ユーザー
-    section 購入
-        カートに追加  : 5: ユーザー
-        決済手続き    : 2: ユーザー
-        注文完了      : 5: ユーザー</a:t>
-            </a:r>
+              <a:t>ユーザー</a:t>
+            </a:r>
+          </a:p>
+        </p:txBody>
+      </p:sp>
+      <p:sp>
+        <p:nvSpPr>
+          <p:cNvPr id="7" name="Rounded Rectangle 6"/>
+          <p:cNvSpPr/>
+          <p:nvPr/>
+        </p:nvSpPr>
+        <p:spPr>
+          <a:xfrm>
+            <a:off x="1557200" y="2143315"/>
+            <a:ext cx="3539800" cy="796569"/>
+          </a:xfrm>
+          <a:prstGeom prst="roundRect">
+            <a:avLst/>
+          </a:prstGeom>
+          <a:solidFill>
+            <a:srgbClr val="5B4AA0"/>
+          </a:solidFill>
+          <a:ln>
+            <a:noFill/>
+          </a:ln>
+        </p:spPr>
+        <p:style>
+          <a:lnRef idx="1">
+            <a:schemeClr val="accent1"/>
+          </a:lnRef>
+          <a:fillRef idx="3">
+            <a:schemeClr val="accent1"/>
+          </a:fillRef>
+          <a:effectRef idx="2">
+            <a:schemeClr val="accent1"/>
+          </a:effectRef>
+          <a:fontRef idx="minor">
+            <a:schemeClr val="lt1"/>
+          </a:fontRef>
+        </p:style>
+        <p:txBody>
+          <a:bodyPr rtlCol="0" anchor="ctr" wrap="square"/>
+          <a:lstStyle/>
+          <a:p>
+            <a:pPr algn="ctr"/>
+            <a:r>
+              <a:rPr sz="1200" b="1">
+                <a:solidFill>
+                  <a:srgbClr val="FFFFFF"/>
+                </a:solidFill>
+              </a:rPr>
+              <a:t>商品探し</a:t>
+            </a:r>
+          </a:p>
+        </p:txBody>
+      </p:sp>
+      <p:sp>
+        <p:nvSpPr>
+          <p:cNvPr id="8" name="Oval 7"/>
+          <p:cNvSpPr/>
+          <p:nvPr/>
+        </p:nvSpPr>
+        <p:spPr>
+          <a:xfrm>
+            <a:off x="1602901" y="2969884"/>
+            <a:ext cx="1055197" cy="1055197"/>
+          </a:xfrm>
+          <a:prstGeom prst="ellipse">
+            <a:avLst/>
+          </a:prstGeom>
+          <a:solidFill>
+            <a:srgbClr val="FFFDC8"/>
+          </a:solidFill>
+          <a:ln w="9525">
+            <a:solidFill>
+              <a:srgbClr val="C8B450"/>
+            </a:solidFill>
+          </a:ln>
+        </p:spPr>
+        <p:style>
+          <a:lnRef idx="1">
+            <a:schemeClr val="accent1"/>
+          </a:lnRef>
+          <a:fillRef idx="3">
+            <a:schemeClr val="accent1"/>
+          </a:fillRef>
+          <a:effectRef idx="2">
+            <a:schemeClr val="accent1"/>
+          </a:effectRef>
+          <a:fontRef idx="minor">
+            <a:schemeClr val="lt1"/>
+          </a:fontRef>
+        </p:style>
+        <p:txBody>
+          <a:bodyPr rtlCol="0" anchor="ctr" wrap="none"/>
+          <a:lstStyle/>
+          <a:p>
+            <a:pPr algn="ctr"/>
+            <a:r>
+              <a:rPr sz="1600"/>
+              <a:t>😊</a:t>
+            </a:r>
+          </a:p>
+        </p:txBody>
+      </p:sp>
+      <p:sp>
+        <p:nvSpPr>
+          <p:cNvPr id="9" name="Rounded Rectangle 8"/>
+          <p:cNvSpPr/>
+          <p:nvPr/>
+        </p:nvSpPr>
+        <p:spPr>
+          <a:xfrm>
+            <a:off x="1597200" y="4095081"/>
+            <a:ext cx="1066600" cy="1274168"/>
+          </a:xfrm>
+          <a:prstGeom prst="roundRect">
+            <a:avLst/>
+          </a:prstGeom>
+          <a:solidFill>
+            <a:srgbClr val="F5F5FA"/>
+          </a:solidFill>
+          <a:ln w="19050">
+            <a:solidFill>
+              <a:srgbClr val="5B4AA0"/>
+            </a:solidFill>
+          </a:ln>
+        </p:spPr>
+        <p:style>
+          <a:lnRef idx="1">
+            <a:schemeClr val="accent1"/>
+          </a:lnRef>
+          <a:fillRef idx="3">
+            <a:schemeClr val="accent1"/>
+          </a:fillRef>
+          <a:effectRef idx="2">
+            <a:schemeClr val="accent1"/>
+          </a:effectRef>
+          <a:fontRef idx="minor">
+            <a:schemeClr val="lt1"/>
+          </a:fontRef>
+        </p:style>
+        <p:txBody>
+          <a:bodyPr rtlCol="0" anchor="ctr" wrap="square"/>
+          <a:lstStyle/>
+          <a:p>
+            <a:pPr algn="ctr"/>
+            <a:r>
+              <a:rPr sz="1100">
+                <a:solidFill>
+                  <a:srgbClr val="28283C"/>
+                </a:solidFill>
+              </a:rPr>
+              <a:t>サイト訪問</a:t>
+            </a:r>
+          </a:p>
+        </p:txBody>
+      </p:sp>
+      <p:sp>
+        <p:nvSpPr>
+          <p:cNvPr id="10" name="Oval 9"/>
+          <p:cNvSpPr/>
+          <p:nvPr/>
+        </p:nvSpPr>
+        <p:spPr>
+          <a:xfrm>
+            <a:off x="2035500" y="5672705"/>
+            <a:ext cx="190000" cy="190000"/>
+          </a:xfrm>
+          <a:prstGeom prst="ellipse">
+            <a:avLst/>
+          </a:prstGeom>
+          <a:solidFill>
+            <a:srgbClr val="8FBC8F"/>
+          </a:solidFill>
+          <a:ln w="9525">
+            <a:solidFill>
+              <a:srgbClr val="505050"/>
+            </a:solidFill>
+          </a:ln>
+        </p:spPr>
+        <p:style>
+          <a:lnRef idx="1">
+            <a:schemeClr val="accent1"/>
+          </a:lnRef>
+          <a:fillRef idx="3">
+            <a:schemeClr val="accent1"/>
+          </a:fillRef>
+          <a:effectRef idx="2">
+            <a:schemeClr val="accent1"/>
+          </a:effectRef>
+          <a:fontRef idx="minor">
+            <a:schemeClr val="lt1"/>
+          </a:fontRef>
+        </p:style>
+        <p:txBody>
+          <a:bodyPr rtlCol="0" anchor="ctr"/>
+          <a:lstStyle/>
+          <a:p>
+            <a:pPr algn="ctr"/>
+          </a:p>
+        </p:txBody>
+      </p:sp>
+      <p:sp>
+        <p:nvSpPr>
+          <p:cNvPr id="11" name="Oval 10"/>
+          <p:cNvSpPr/>
+          <p:nvPr/>
+        </p:nvSpPr>
+        <p:spPr>
+          <a:xfrm>
+            <a:off x="2799501" y="2969884"/>
+            <a:ext cx="1055197" cy="1055197"/>
+          </a:xfrm>
+          <a:prstGeom prst="ellipse">
+            <a:avLst/>
+          </a:prstGeom>
+          <a:solidFill>
+            <a:srgbClr val="FFFDC8"/>
+          </a:solidFill>
+          <a:ln w="9525">
+            <a:solidFill>
+              <a:srgbClr val="C8B450"/>
+            </a:solidFill>
+          </a:ln>
+        </p:spPr>
+        <p:style>
+          <a:lnRef idx="1">
+            <a:schemeClr val="accent1"/>
+          </a:lnRef>
+          <a:fillRef idx="3">
+            <a:schemeClr val="accent1"/>
+          </a:fillRef>
+          <a:effectRef idx="2">
+            <a:schemeClr val="accent1"/>
+          </a:effectRef>
+          <a:fontRef idx="minor">
+            <a:schemeClr val="lt1"/>
+          </a:fontRef>
+        </p:style>
+        <p:txBody>
+          <a:bodyPr rtlCol="0" anchor="ctr" wrap="none"/>
+          <a:lstStyle/>
+          <a:p>
+            <a:pPr algn="ctr"/>
+            <a:r>
+              <a:rPr sz="1600"/>
+              <a:t>😐</a:t>
+            </a:r>
+          </a:p>
+        </p:txBody>
+      </p:sp>
+      <p:sp>
+        <p:nvSpPr>
+          <p:cNvPr id="12" name="Rounded Rectangle 11"/>
+          <p:cNvSpPr/>
+          <p:nvPr/>
+        </p:nvSpPr>
+        <p:spPr>
+          <a:xfrm>
+            <a:off x="2793800" y="4095081"/>
+            <a:ext cx="1066600" cy="1274168"/>
+          </a:xfrm>
+          <a:prstGeom prst="roundRect">
+            <a:avLst/>
+          </a:prstGeom>
+          <a:solidFill>
+            <a:srgbClr val="F5F5FA"/>
+          </a:solidFill>
+          <a:ln w="19050">
+            <a:solidFill>
+              <a:srgbClr val="5B4AA0"/>
+            </a:solidFill>
+          </a:ln>
+        </p:spPr>
+        <p:style>
+          <a:lnRef idx="1">
+            <a:schemeClr val="accent1"/>
+          </a:lnRef>
+          <a:fillRef idx="3">
+            <a:schemeClr val="accent1"/>
+          </a:fillRef>
+          <a:effectRef idx="2">
+            <a:schemeClr val="accent1"/>
+          </a:effectRef>
+          <a:fontRef idx="minor">
+            <a:schemeClr val="lt1"/>
+          </a:fontRef>
+        </p:style>
+        <p:txBody>
+          <a:bodyPr rtlCol="0" anchor="ctr" wrap="square"/>
+          <a:lstStyle/>
+          <a:p>
+            <a:pPr algn="ctr"/>
+            <a:r>
+              <a:rPr sz="1100">
+                <a:solidFill>
+                  <a:srgbClr val="28283C"/>
+                </a:solidFill>
+              </a:rPr>
+              <a:t>検索実行</a:t>
+            </a:r>
+          </a:p>
+        </p:txBody>
+      </p:sp>
+      <p:sp>
+        <p:nvSpPr>
+          <p:cNvPr id="13" name="Oval 12"/>
+          <p:cNvSpPr/>
+          <p:nvPr/>
+        </p:nvSpPr>
+        <p:spPr>
+          <a:xfrm>
+            <a:off x="3232100" y="5672705"/>
+            <a:ext cx="190000" cy="190000"/>
+          </a:xfrm>
+          <a:prstGeom prst="ellipse">
+            <a:avLst/>
+          </a:prstGeom>
+          <a:solidFill>
+            <a:srgbClr val="8FBC8F"/>
+          </a:solidFill>
+          <a:ln w="9525">
+            <a:solidFill>
+              <a:srgbClr val="505050"/>
+            </a:solidFill>
+          </a:ln>
+        </p:spPr>
+        <p:style>
+          <a:lnRef idx="1">
+            <a:schemeClr val="accent1"/>
+          </a:lnRef>
+          <a:fillRef idx="3">
+            <a:schemeClr val="accent1"/>
+          </a:fillRef>
+          <a:effectRef idx="2">
+            <a:schemeClr val="accent1"/>
+          </a:effectRef>
+          <a:fontRef idx="minor">
+            <a:schemeClr val="lt1"/>
+          </a:fontRef>
+        </p:style>
+        <p:txBody>
+          <a:bodyPr rtlCol="0" anchor="ctr"/>
+          <a:lstStyle/>
+          <a:p>
+            <a:pPr algn="ctr"/>
+          </a:p>
+        </p:txBody>
+      </p:sp>
+      <p:sp>
+        <p:nvSpPr>
+          <p:cNvPr id="14" name="Oval 13"/>
+          <p:cNvSpPr/>
+          <p:nvPr/>
+        </p:nvSpPr>
+        <p:spPr>
+          <a:xfrm>
+            <a:off x="3996101" y="2969884"/>
+            <a:ext cx="1055197" cy="1055197"/>
+          </a:xfrm>
+          <a:prstGeom prst="ellipse">
+            <a:avLst/>
+          </a:prstGeom>
+          <a:solidFill>
+            <a:srgbClr val="FFFDC8"/>
+          </a:solidFill>
+          <a:ln w="9525">
+            <a:solidFill>
+              <a:srgbClr val="C8B450"/>
+            </a:solidFill>
+          </a:ln>
+        </p:spPr>
+        <p:style>
+          <a:lnRef idx="1">
+            <a:schemeClr val="accent1"/>
+          </a:lnRef>
+          <a:fillRef idx="3">
+            <a:schemeClr val="accent1"/>
+          </a:fillRef>
+          <a:effectRef idx="2">
+            <a:schemeClr val="accent1"/>
+          </a:effectRef>
+          <a:fontRef idx="minor">
+            <a:schemeClr val="lt1"/>
+          </a:fontRef>
+        </p:style>
+        <p:txBody>
+          <a:bodyPr rtlCol="0" anchor="ctr" wrap="none"/>
+          <a:lstStyle/>
+          <a:p>
+            <a:pPr algn="ctr"/>
+            <a:r>
+              <a:rPr sz="1600"/>
+              <a:t>😊</a:t>
+            </a:r>
+          </a:p>
+        </p:txBody>
+      </p:sp>
+      <p:sp>
+        <p:nvSpPr>
+          <p:cNvPr id="15" name="Rounded Rectangle 14"/>
+          <p:cNvSpPr/>
+          <p:nvPr/>
+        </p:nvSpPr>
+        <p:spPr>
+          <a:xfrm>
+            <a:off x="3990400" y="4095081"/>
+            <a:ext cx="1066600" cy="1274168"/>
+          </a:xfrm>
+          <a:prstGeom prst="roundRect">
+            <a:avLst/>
+          </a:prstGeom>
+          <a:solidFill>
+            <a:srgbClr val="F5F5FA"/>
+          </a:solidFill>
+          <a:ln w="19050">
+            <a:solidFill>
+              <a:srgbClr val="5B4AA0"/>
+            </a:solidFill>
+          </a:ln>
+        </p:spPr>
+        <p:style>
+          <a:lnRef idx="1">
+            <a:schemeClr val="accent1"/>
+          </a:lnRef>
+          <a:fillRef idx="3">
+            <a:schemeClr val="accent1"/>
+          </a:fillRef>
+          <a:effectRef idx="2">
+            <a:schemeClr val="accent1"/>
+          </a:effectRef>
+          <a:fontRef idx="minor">
+            <a:schemeClr val="lt1"/>
+          </a:fontRef>
+        </p:style>
+        <p:txBody>
+          <a:bodyPr rtlCol="0" anchor="ctr" wrap="square"/>
+          <a:lstStyle/>
+          <a:p>
+            <a:pPr algn="ctr"/>
+            <a:r>
+              <a:rPr sz="1100">
+                <a:solidFill>
+                  <a:srgbClr val="28283C"/>
+                </a:solidFill>
+              </a:rPr>
+              <a:t>商品選択</a:t>
+            </a:r>
+          </a:p>
+        </p:txBody>
+      </p:sp>
+      <p:sp>
+        <p:nvSpPr>
+          <p:cNvPr id="16" name="Oval 15"/>
+          <p:cNvSpPr/>
+          <p:nvPr/>
+        </p:nvSpPr>
+        <p:spPr>
+          <a:xfrm>
+            <a:off x="4428700" y="5672705"/>
+            <a:ext cx="190000" cy="190000"/>
+          </a:xfrm>
+          <a:prstGeom prst="ellipse">
+            <a:avLst/>
+          </a:prstGeom>
+          <a:solidFill>
+            <a:srgbClr val="8FBC8F"/>
+          </a:solidFill>
+          <a:ln w="9525">
+            <a:solidFill>
+              <a:srgbClr val="505050"/>
+            </a:solidFill>
+          </a:ln>
+        </p:spPr>
+        <p:style>
+          <a:lnRef idx="1">
+            <a:schemeClr val="accent1"/>
+          </a:lnRef>
+          <a:fillRef idx="3">
+            <a:schemeClr val="accent1"/>
+          </a:fillRef>
+          <a:effectRef idx="2">
+            <a:schemeClr val="accent1"/>
+          </a:effectRef>
+          <a:fontRef idx="minor">
+            <a:schemeClr val="lt1"/>
+          </a:fontRef>
+        </p:style>
+        <p:txBody>
+          <a:bodyPr rtlCol="0" anchor="ctr"/>
+          <a:lstStyle/>
+          <a:p>
+            <a:pPr algn="ctr"/>
+          </a:p>
+        </p:txBody>
+      </p:sp>
+      <p:sp>
+        <p:nvSpPr>
+          <p:cNvPr id="17" name="Rounded Rectangle 16"/>
+          <p:cNvSpPr/>
+          <p:nvPr/>
+        </p:nvSpPr>
+        <p:spPr>
+          <a:xfrm>
+            <a:off x="5147000" y="2143315"/>
+            <a:ext cx="3539800" cy="796569"/>
+          </a:xfrm>
+          <a:prstGeom prst="roundRect">
+            <a:avLst/>
+          </a:prstGeom>
+          <a:solidFill>
+            <a:srgbClr val="2E64A0"/>
+          </a:solidFill>
+          <a:ln>
+            <a:noFill/>
+          </a:ln>
+        </p:spPr>
+        <p:style>
+          <a:lnRef idx="1">
+            <a:schemeClr val="accent1"/>
+          </a:lnRef>
+          <a:fillRef idx="3">
+            <a:schemeClr val="accent1"/>
+          </a:fillRef>
+          <a:effectRef idx="2">
+            <a:schemeClr val="accent1"/>
+          </a:effectRef>
+          <a:fontRef idx="minor">
+            <a:schemeClr val="lt1"/>
+          </a:fontRef>
+        </p:style>
+        <p:txBody>
+          <a:bodyPr rtlCol="0" anchor="ctr" wrap="square"/>
+          <a:lstStyle/>
+          <a:p>
+            <a:pPr algn="ctr"/>
+            <a:r>
+              <a:rPr sz="1200" b="1">
+                <a:solidFill>
+                  <a:srgbClr val="FFFFFF"/>
+                </a:solidFill>
+              </a:rPr>
+              <a:t>購入</a:t>
+            </a:r>
+          </a:p>
+        </p:txBody>
+      </p:sp>
+      <p:sp>
+        <p:nvSpPr>
+          <p:cNvPr id="18" name="Oval 17"/>
+          <p:cNvSpPr/>
+          <p:nvPr/>
+        </p:nvSpPr>
+        <p:spPr>
+          <a:xfrm>
+            <a:off x="5192701" y="2969884"/>
+            <a:ext cx="1055197" cy="1055197"/>
+          </a:xfrm>
+          <a:prstGeom prst="ellipse">
+            <a:avLst/>
+          </a:prstGeom>
+          <a:solidFill>
+            <a:srgbClr val="FFFDC8"/>
+          </a:solidFill>
+          <a:ln w="9525">
+            <a:solidFill>
+              <a:srgbClr val="C8B450"/>
+            </a:solidFill>
+          </a:ln>
+        </p:spPr>
+        <p:style>
+          <a:lnRef idx="1">
+            <a:schemeClr val="accent1"/>
+          </a:lnRef>
+          <a:fillRef idx="3">
+            <a:schemeClr val="accent1"/>
+          </a:fillRef>
+          <a:effectRef idx="2">
+            <a:schemeClr val="accent1"/>
+          </a:effectRef>
+          <a:fontRef idx="minor">
+            <a:schemeClr val="lt1"/>
+          </a:fontRef>
+        </p:style>
+        <p:txBody>
+          <a:bodyPr rtlCol="0" anchor="ctr" wrap="none"/>
+          <a:lstStyle/>
+          <a:p>
+            <a:pPr algn="ctr"/>
+            <a:r>
+              <a:rPr sz="1600"/>
+              <a:t>😊</a:t>
+            </a:r>
+          </a:p>
+        </p:txBody>
+      </p:sp>
+      <p:sp>
+        <p:nvSpPr>
+          <p:cNvPr id="19" name="Rounded Rectangle 18"/>
+          <p:cNvSpPr/>
+          <p:nvPr/>
+        </p:nvSpPr>
+        <p:spPr>
+          <a:xfrm>
+            <a:off x="5187000" y="4095081"/>
+            <a:ext cx="1066600" cy="1274168"/>
+          </a:xfrm>
+          <a:prstGeom prst="roundRect">
+            <a:avLst/>
+          </a:prstGeom>
+          <a:solidFill>
+            <a:srgbClr val="F5F5FA"/>
+          </a:solidFill>
+          <a:ln w="19050">
+            <a:solidFill>
+              <a:srgbClr val="2E64A0"/>
+            </a:solidFill>
+          </a:ln>
+        </p:spPr>
+        <p:style>
+          <a:lnRef idx="1">
+            <a:schemeClr val="accent1"/>
+          </a:lnRef>
+          <a:fillRef idx="3">
+            <a:schemeClr val="accent1"/>
+          </a:fillRef>
+          <a:effectRef idx="2">
+            <a:schemeClr val="accent1"/>
+          </a:effectRef>
+          <a:fontRef idx="minor">
+            <a:schemeClr val="lt1"/>
+          </a:fontRef>
+        </p:style>
+        <p:txBody>
+          <a:bodyPr rtlCol="0" anchor="ctr" wrap="square"/>
+          <a:lstStyle/>
+          <a:p>
+            <a:pPr algn="ctr"/>
+            <a:r>
+              <a:rPr sz="1100">
+                <a:solidFill>
+                  <a:srgbClr val="28283C"/>
+                </a:solidFill>
+              </a:rPr>
+              <a:t>カートに追加</a:t>
+            </a:r>
+          </a:p>
+        </p:txBody>
+      </p:sp>
+      <p:sp>
+        <p:nvSpPr>
+          <p:cNvPr id="20" name="Oval 19"/>
+          <p:cNvSpPr/>
+          <p:nvPr/>
+        </p:nvSpPr>
+        <p:spPr>
+          <a:xfrm>
+            <a:off x="5625300" y="5672705"/>
+            <a:ext cx="190000" cy="190000"/>
+          </a:xfrm>
+          <a:prstGeom prst="ellipse">
+            <a:avLst/>
+          </a:prstGeom>
+          <a:solidFill>
+            <a:srgbClr val="8FBC8F"/>
+          </a:solidFill>
+          <a:ln w="9525">
+            <a:solidFill>
+              <a:srgbClr val="505050"/>
+            </a:solidFill>
+          </a:ln>
+        </p:spPr>
+        <p:style>
+          <a:lnRef idx="1">
+            <a:schemeClr val="accent1"/>
+          </a:lnRef>
+          <a:fillRef idx="3">
+            <a:schemeClr val="accent1"/>
+          </a:fillRef>
+          <a:effectRef idx="2">
+            <a:schemeClr val="accent1"/>
+          </a:effectRef>
+          <a:fontRef idx="minor">
+            <a:schemeClr val="lt1"/>
+          </a:fontRef>
+        </p:style>
+        <p:txBody>
+          <a:bodyPr rtlCol="0" anchor="ctr"/>
+          <a:lstStyle/>
+          <a:p>
+            <a:pPr algn="ctr"/>
+          </a:p>
+        </p:txBody>
+      </p:sp>
+      <p:sp>
+        <p:nvSpPr>
+          <p:cNvPr id="21" name="Oval 20"/>
+          <p:cNvSpPr/>
+          <p:nvPr/>
+        </p:nvSpPr>
+        <p:spPr>
+          <a:xfrm>
+            <a:off x="6389301" y="2969884"/>
+            <a:ext cx="1055197" cy="1055197"/>
+          </a:xfrm>
+          <a:prstGeom prst="ellipse">
+            <a:avLst/>
+          </a:prstGeom>
+          <a:solidFill>
+            <a:srgbClr val="FFFDC8"/>
+          </a:solidFill>
+          <a:ln w="9525">
+            <a:solidFill>
+              <a:srgbClr val="C8B450"/>
+            </a:solidFill>
+          </a:ln>
+        </p:spPr>
+        <p:style>
+          <a:lnRef idx="1">
+            <a:schemeClr val="accent1"/>
+          </a:lnRef>
+          <a:fillRef idx="3">
+            <a:schemeClr val="accent1"/>
+          </a:fillRef>
+          <a:effectRef idx="2">
+            <a:schemeClr val="accent1"/>
+          </a:effectRef>
+          <a:fontRef idx="minor">
+            <a:schemeClr val="lt1"/>
+          </a:fontRef>
+        </p:style>
+        <p:txBody>
+          <a:bodyPr rtlCol="0" anchor="ctr" wrap="none"/>
+          <a:lstStyle/>
+          <a:p>
+            <a:pPr algn="ctr"/>
+            <a:r>
+              <a:rPr sz="1600"/>
+              <a:t>😢</a:t>
+            </a:r>
+          </a:p>
+        </p:txBody>
+      </p:sp>
+      <p:sp>
+        <p:nvSpPr>
+          <p:cNvPr id="22" name="Rounded Rectangle 21"/>
+          <p:cNvSpPr/>
+          <p:nvPr/>
+        </p:nvSpPr>
+        <p:spPr>
+          <a:xfrm>
+            <a:off x="6383600" y="4095081"/>
+            <a:ext cx="1066600" cy="1274168"/>
+          </a:xfrm>
+          <a:prstGeom prst="roundRect">
+            <a:avLst/>
+          </a:prstGeom>
+          <a:solidFill>
+            <a:srgbClr val="F5F5FA"/>
+          </a:solidFill>
+          <a:ln w="19050">
+            <a:solidFill>
+              <a:srgbClr val="2E64A0"/>
+            </a:solidFill>
+          </a:ln>
+        </p:spPr>
+        <p:style>
+          <a:lnRef idx="1">
+            <a:schemeClr val="accent1"/>
+          </a:lnRef>
+          <a:fillRef idx="3">
+            <a:schemeClr val="accent1"/>
+          </a:fillRef>
+          <a:effectRef idx="2">
+            <a:schemeClr val="accent1"/>
+          </a:effectRef>
+          <a:fontRef idx="minor">
+            <a:schemeClr val="lt1"/>
+          </a:fontRef>
+        </p:style>
+        <p:txBody>
+          <a:bodyPr rtlCol="0" anchor="ctr" wrap="square"/>
+          <a:lstStyle/>
+          <a:p>
+            <a:pPr algn="ctr"/>
+            <a:r>
+              <a:rPr sz="1100">
+                <a:solidFill>
+                  <a:srgbClr val="28283C"/>
+                </a:solidFill>
+              </a:rPr>
+              <a:t>決済手続き</a:t>
+            </a:r>
+          </a:p>
+        </p:txBody>
+      </p:sp>
+      <p:sp>
+        <p:nvSpPr>
+          <p:cNvPr id="23" name="Oval 22"/>
+          <p:cNvSpPr/>
+          <p:nvPr/>
+        </p:nvSpPr>
+        <p:spPr>
+          <a:xfrm>
+            <a:off x="6821900" y="5672705"/>
+            <a:ext cx="190000" cy="190000"/>
+          </a:xfrm>
+          <a:prstGeom prst="ellipse">
+            <a:avLst/>
+          </a:prstGeom>
+          <a:solidFill>
+            <a:srgbClr val="8FBC8F"/>
+          </a:solidFill>
+          <a:ln w="9525">
+            <a:solidFill>
+              <a:srgbClr val="505050"/>
+            </a:solidFill>
+          </a:ln>
+        </p:spPr>
+        <p:style>
+          <a:lnRef idx="1">
+            <a:schemeClr val="accent1"/>
+          </a:lnRef>
+          <a:fillRef idx="3">
+            <a:schemeClr val="accent1"/>
+          </a:fillRef>
+          <a:effectRef idx="2">
+            <a:schemeClr val="accent1"/>
+          </a:effectRef>
+          <a:fontRef idx="minor">
+            <a:schemeClr val="lt1"/>
+          </a:fontRef>
+        </p:style>
+        <p:txBody>
+          <a:bodyPr rtlCol="0" anchor="ctr"/>
+          <a:lstStyle/>
+          <a:p>
+            <a:pPr algn="ctr"/>
+          </a:p>
+        </p:txBody>
+      </p:sp>
+      <p:sp>
+        <p:nvSpPr>
+          <p:cNvPr id="24" name="Oval 23"/>
+          <p:cNvSpPr/>
+          <p:nvPr/>
+        </p:nvSpPr>
+        <p:spPr>
+          <a:xfrm>
+            <a:off x="7585901" y="2969884"/>
+            <a:ext cx="1055197" cy="1055197"/>
+          </a:xfrm>
+          <a:prstGeom prst="ellipse">
+            <a:avLst/>
+          </a:prstGeom>
+          <a:solidFill>
+            <a:srgbClr val="FFFDC8"/>
+          </a:solidFill>
+          <a:ln w="9525">
+            <a:solidFill>
+              <a:srgbClr val="C8B450"/>
+            </a:solidFill>
+          </a:ln>
+        </p:spPr>
+        <p:style>
+          <a:lnRef idx="1">
+            <a:schemeClr val="accent1"/>
+          </a:lnRef>
+          <a:fillRef idx="3">
+            <a:schemeClr val="accent1"/>
+          </a:fillRef>
+          <a:effectRef idx="2">
+            <a:schemeClr val="accent1"/>
+          </a:effectRef>
+          <a:fontRef idx="minor">
+            <a:schemeClr val="lt1"/>
+          </a:fontRef>
+        </p:style>
+        <p:txBody>
+          <a:bodyPr rtlCol="0" anchor="ctr" wrap="none"/>
+          <a:lstStyle/>
+          <a:p>
+            <a:pPr algn="ctr"/>
+            <a:r>
+              <a:rPr sz="1600"/>
+              <a:t>😊</a:t>
+            </a:r>
+          </a:p>
+        </p:txBody>
+      </p:sp>
+      <p:sp>
+        <p:nvSpPr>
+          <p:cNvPr id="25" name="Rounded Rectangle 24"/>
+          <p:cNvSpPr/>
+          <p:nvPr/>
+        </p:nvSpPr>
+        <p:spPr>
+          <a:xfrm>
+            <a:off x="7580200" y="4095081"/>
+            <a:ext cx="1066600" cy="1274168"/>
+          </a:xfrm>
+          <a:prstGeom prst="roundRect">
+            <a:avLst/>
+          </a:prstGeom>
+          <a:solidFill>
+            <a:srgbClr val="F5F5FA"/>
+          </a:solidFill>
+          <a:ln w="19050">
+            <a:solidFill>
+              <a:srgbClr val="2E64A0"/>
+            </a:solidFill>
+          </a:ln>
+        </p:spPr>
+        <p:style>
+          <a:lnRef idx="1">
+            <a:schemeClr val="accent1"/>
+          </a:lnRef>
+          <a:fillRef idx="3">
+            <a:schemeClr val="accent1"/>
+          </a:fillRef>
+          <a:effectRef idx="2">
+            <a:schemeClr val="accent1"/>
+          </a:effectRef>
+          <a:fontRef idx="minor">
+            <a:schemeClr val="lt1"/>
+          </a:fontRef>
+        </p:style>
+        <p:txBody>
+          <a:bodyPr rtlCol="0" anchor="ctr" wrap="square"/>
+          <a:lstStyle/>
+          <a:p>
+            <a:pPr algn="ctr"/>
+            <a:r>
+              <a:rPr sz="1100">
+                <a:solidFill>
+                  <a:srgbClr val="28283C"/>
+                </a:solidFill>
+              </a:rPr>
+              <a:t>注文完了</a:t>
+            </a:r>
+          </a:p>
+        </p:txBody>
+      </p:sp>
+      <p:sp>
+        <p:nvSpPr>
+          <p:cNvPr id="26" name="Oval 25"/>
+          <p:cNvSpPr/>
+          <p:nvPr/>
+        </p:nvSpPr>
+        <p:spPr>
+          <a:xfrm>
+            <a:off x="8018500" y="5672705"/>
+            <a:ext cx="190000" cy="190000"/>
+          </a:xfrm>
+          <a:prstGeom prst="ellipse">
+            <a:avLst/>
+          </a:prstGeom>
+          <a:solidFill>
+            <a:srgbClr val="8FBC8F"/>
+          </a:solidFill>
+          <a:ln w="9525">
+            <a:solidFill>
+              <a:srgbClr val="505050"/>
+            </a:solidFill>
+          </a:ln>
+        </p:spPr>
+        <p:style>
+          <a:lnRef idx="1">
+            <a:schemeClr val="accent1"/>
+          </a:lnRef>
+          <a:fillRef idx="3">
+            <a:schemeClr val="accent1"/>
+          </a:fillRef>
+          <a:effectRef idx="2">
+            <a:schemeClr val="accent1"/>
+          </a:effectRef>
+          <a:fontRef idx="minor">
+            <a:schemeClr val="lt1"/>
+          </a:fontRef>
+        </p:style>
+        <p:txBody>
+          <a:bodyPr rtlCol="0" anchor="ctr"/>
+          <a:lstStyle/>
+          <a:p>
+            <a:pPr algn="ctr"/>
           </a:p>
         </p:txBody>
       </p:sp>

</xml_diff>

<commit_message>
Add quadrant chart support with parser and renderer
- Implemented `parse_quadrant` function to parse Mermaid quadrant chart syntax.
- Created `QuadrantRenderer` to render quadrant charts on slides.
- Updated `MermaidRenderer` to handle quadrant charts in addition to existing chart types.
- Added comprehensive unit tests for `QuadrantParser` and `QuadrantRenderer` to ensure correct functionality and error handling.
</commit_message>
<xml_diff>
--- a/demo_full.pptx
+++ b/demo_full.pptx
@@ -13923,7 +13923,84 @@
         </p:nvSpPr>
         <p:spPr>
           <a:xfrm>
-            <a:off x="2272000" y="2188180"/>
+            <a:off x="2872000" y="2653181"/>
+            <a:ext cx="3400000" cy="2420000"/>
+          </a:xfrm>
+          <a:prstGeom prst="roundRect">
+            <a:avLst/>
+          </a:prstGeom>
+          <a:solidFill>
+            <a:srgbClr val="EEF4FF"/>
+          </a:solidFill>
+          <a:ln>
+            <a:solidFill>
+              <a:srgbClr val="4664AA"/>
+            </a:solidFill>
+          </a:ln>
+        </p:spPr>
+        <p:style>
+          <a:lnRef idx="1">
+            <a:schemeClr val="accent1"/>
+          </a:lnRef>
+          <a:fillRef idx="3">
+            <a:schemeClr val="accent1"/>
+          </a:fillRef>
+          <a:effectRef idx="2">
+            <a:schemeClr val="accent1"/>
+          </a:effectRef>
+          <a:fontRef idx="minor">
+            <a:schemeClr val="lt1"/>
+          </a:fontRef>
+        </p:style>
+        <p:txBody>
+          <a:bodyPr rtlCol="0" anchor="ctr"/>
+          <a:lstStyle/>
+          <a:p/>
+        </p:txBody>
+      </p:sp>
+      <p:sp>
+        <p:nvSpPr>
+          <p:cNvPr id="5" name="TextBox 4"/>
+          <p:cNvSpPr txBox="1"/>
+          <p:nvPr/>
+        </p:nvSpPr>
+        <p:spPr>
+          <a:xfrm>
+            <a:off x="2872000" y="2653181"/>
+            <a:ext cx="3400000" cy="420000"/>
+          </a:xfrm>
+          <a:prstGeom prst="rect">
+            <a:avLst/>
+          </a:prstGeom>
+          <a:noFill/>
+        </p:spPr>
+        <p:txBody>
+          <a:bodyPr wrap="none">
+            <a:spAutoFit/>
+          </a:bodyPr>
+          <a:lstStyle/>
+          <a:p>
+            <a:pPr algn="ctr"/>
+            <a:r>
+              <a:rPr sz="1100" b="1">
+                <a:solidFill>
+                  <a:srgbClr val="4664AA"/>
+                </a:solidFill>
+              </a:rPr>
+              <a:t>Active</a:t>
+            </a:r>
+          </a:p>
+        </p:txBody>
+      </p:sp>
+      <p:sp>
+        <p:nvSpPr>
+          <p:cNvPr id="6" name="Rounded Rectangle 5"/>
+          <p:cNvSpPr/>
+          <p:nvPr/>
+        </p:nvSpPr>
+        <p:spPr>
+          <a:xfrm>
+            <a:off x="2272000" y="3538181"/>
             <a:ext cx="4600000" cy="2420000"/>
           </a:xfrm>
           <a:prstGeom prst="roundRect">
@@ -13961,90 +14038,13 @@
       </p:sp>
       <p:sp>
         <p:nvSpPr>
-          <p:cNvPr id="5" name="Rounded Rectangle 4"/>
-          <p:cNvSpPr/>
-          <p:nvPr/>
-        </p:nvSpPr>
-        <p:spPr>
-          <a:xfrm>
-            <a:off x="2872000" y="2653181"/>
-            <a:ext cx="3400000" cy="2420000"/>
-          </a:xfrm>
-          <a:prstGeom prst="roundRect">
-            <a:avLst/>
-          </a:prstGeom>
-          <a:solidFill>
-            <a:srgbClr val="EEF4FF"/>
-          </a:solidFill>
-          <a:ln>
-            <a:solidFill>
-              <a:srgbClr val="4664AA"/>
-            </a:solidFill>
-          </a:ln>
-        </p:spPr>
-        <p:style>
-          <a:lnRef idx="1">
-            <a:schemeClr val="accent1"/>
-          </a:lnRef>
-          <a:fillRef idx="3">
-            <a:schemeClr val="accent1"/>
-          </a:fillRef>
-          <a:effectRef idx="2">
-            <a:schemeClr val="accent1"/>
-          </a:effectRef>
-          <a:fontRef idx="minor">
-            <a:schemeClr val="lt1"/>
-          </a:fontRef>
-        </p:style>
-        <p:txBody>
-          <a:bodyPr rtlCol="0" anchor="ctr"/>
-          <a:lstStyle/>
-          <a:p/>
-        </p:txBody>
-      </p:sp>
-      <p:sp>
-        <p:nvSpPr>
-          <p:cNvPr id="6" name="TextBox 5"/>
-          <p:cNvSpPr txBox="1"/>
-          <p:nvPr/>
-        </p:nvSpPr>
-        <p:spPr>
-          <a:xfrm>
-            <a:off x="2872000" y="2653181"/>
-            <a:ext cx="3400000" cy="420000"/>
-          </a:xfrm>
-          <a:prstGeom prst="rect">
-            <a:avLst/>
-          </a:prstGeom>
-          <a:noFill/>
-        </p:spPr>
-        <p:txBody>
-          <a:bodyPr wrap="none">
-            <a:spAutoFit/>
-          </a:bodyPr>
-          <a:lstStyle/>
-          <a:p>
-            <a:pPr algn="ctr"/>
-            <a:r>
-              <a:rPr sz="1100" b="1">
-                <a:solidFill>
-                  <a:srgbClr val="4664AA"/>
-                </a:solidFill>
-              </a:rPr>
-              <a:t>Active</a:t>
-            </a:r>
-          </a:p>
-        </p:txBody>
-      </p:sp>
-      <p:sp>
-        <p:nvSpPr>
           <p:cNvPr id="7" name="Rounded Rectangle 6"/>
           <p:cNvSpPr/>
           <p:nvPr/>
         </p:nvSpPr>
         <p:spPr>
           <a:xfrm>
-            <a:off x="2272000" y="3538181"/>
+            <a:off x="2272000" y="2188180"/>
             <a:ext cx="4600000" cy="2420000"/>
           </a:xfrm>
           <a:prstGeom prst="roundRect">
@@ -14342,7 +14342,7 @@
           <p:cNvPr id="18" name="Connector 17"/>
           <p:cNvCxnSpPr>
             <a:stCxn id="8" idx="3"/>
-            <a:endCxn id="5" idx="1"/>
+            <a:endCxn id="4" idx="1"/>
           </p:cNvCxnSpPr>
           <p:nvPr/>
         </p:nvCxnSpPr>
@@ -14593,7 +14593,7 @@
         <p:nvCxnSpPr>
           <p:cNvPr id="29" name="Connector 28"/>
           <p:cNvCxnSpPr>
-            <a:stCxn id="5" idx="3"/>
+            <a:stCxn id="4" idx="3"/>
             <a:endCxn id="9" idx="1"/>
           </p:cNvCxnSpPr>
           <p:nvPr/>
@@ -19084,7 +19084,326 @@
         <p:spPr>
           <a:xfrm>
             <a:off x="457200" y="1600200"/>
-            <a:ext cx="8229600" cy="4525963"/>
+            <a:ext cx="8229600" cy="362077"/>
+          </a:xfrm>
+          <a:prstGeom prst="rect">
+            <a:avLst/>
+          </a:prstGeom>
+          <a:noFill/>
+        </p:spPr>
+        <p:txBody>
+          <a:bodyPr wrap="none">
+            <a:spAutoFit/>
+          </a:bodyPr>
+          <a:lstStyle/>
+          <a:p>
+            <a:pPr algn="ctr"/>
+            <a:r>
+              <a:rPr sz="2000" b="1">
+                <a:solidFill>
+                  <a:srgbClr val="1E1E3C"/>
+                </a:solidFill>
+              </a:rPr>
+              <a:t>製品ポートフォリオ分析</a:t>
+            </a:r>
+          </a:p>
+        </p:txBody>
+      </p:sp>
+      <p:sp>
+        <p:nvSpPr>
+          <p:cNvPr id="5" name="Rectangle 4"/>
+          <p:cNvSpPr/>
+          <p:nvPr/>
+        </p:nvSpPr>
+        <p:spPr>
+          <a:xfrm>
+            <a:off x="1033272" y="1962277"/>
+            <a:ext cx="3826764" cy="1878275"/>
+          </a:xfrm>
+          <a:prstGeom prst="rect">
+            <a:avLst/>
+          </a:prstGeom>
+          <a:solidFill>
+            <a:srgbClr val="D0E4FF"/>
+          </a:solidFill>
+          <a:ln>
+            <a:noFill/>
+          </a:ln>
+        </p:spPr>
+        <p:style>
+          <a:lnRef idx="1">
+            <a:schemeClr val="accent1"/>
+          </a:lnRef>
+          <a:fillRef idx="3">
+            <a:schemeClr val="accent1"/>
+          </a:fillRef>
+          <a:effectRef idx="2">
+            <a:schemeClr val="accent1"/>
+          </a:effectRef>
+          <a:fontRef idx="minor">
+            <a:schemeClr val="lt1"/>
+          </a:fontRef>
+        </p:style>
+        <p:txBody>
+          <a:bodyPr rtlCol="0" anchor="ctr"/>
+          <a:lstStyle/>
+          <a:p>
+            <a:pPr algn="ctr"/>
+          </a:p>
+        </p:txBody>
+      </p:sp>
+      <p:sp>
+        <p:nvSpPr>
+          <p:cNvPr id="6" name="Rectangle 5"/>
+          <p:cNvSpPr/>
+          <p:nvPr/>
+        </p:nvSpPr>
+        <p:spPr>
+          <a:xfrm>
+            <a:off x="4860036" y="1962277"/>
+            <a:ext cx="3826764" cy="1878275"/>
+          </a:xfrm>
+          <a:prstGeom prst="rect">
+            <a:avLst/>
+          </a:prstGeom>
+          <a:solidFill>
+            <a:srgbClr val="ECEAFF"/>
+          </a:solidFill>
+          <a:ln>
+            <a:noFill/>
+          </a:ln>
+        </p:spPr>
+        <p:style>
+          <a:lnRef idx="1">
+            <a:schemeClr val="accent1"/>
+          </a:lnRef>
+          <a:fillRef idx="3">
+            <a:schemeClr val="accent1"/>
+          </a:fillRef>
+          <a:effectRef idx="2">
+            <a:schemeClr val="accent1"/>
+          </a:effectRef>
+          <a:fontRef idx="minor">
+            <a:schemeClr val="lt1"/>
+          </a:fontRef>
+        </p:style>
+        <p:txBody>
+          <a:bodyPr rtlCol="0" anchor="ctr"/>
+          <a:lstStyle/>
+          <a:p>
+            <a:pPr algn="ctr"/>
+          </a:p>
+        </p:txBody>
+      </p:sp>
+      <p:sp>
+        <p:nvSpPr>
+          <p:cNvPr id="7" name="Rectangle 6"/>
+          <p:cNvSpPr/>
+          <p:nvPr/>
+        </p:nvSpPr>
+        <p:spPr>
+          <a:xfrm>
+            <a:off x="1033272" y="3840552"/>
+            <a:ext cx="3826764" cy="1878275"/>
+          </a:xfrm>
+          <a:prstGeom prst="rect">
+            <a:avLst/>
+          </a:prstGeom>
+          <a:solidFill>
+            <a:srgbClr val="FFF4D0"/>
+          </a:solidFill>
+          <a:ln>
+            <a:noFill/>
+          </a:ln>
+        </p:spPr>
+        <p:style>
+          <a:lnRef idx="1">
+            <a:schemeClr val="accent1"/>
+          </a:lnRef>
+          <a:fillRef idx="3">
+            <a:schemeClr val="accent1"/>
+          </a:fillRef>
+          <a:effectRef idx="2">
+            <a:schemeClr val="accent1"/>
+          </a:effectRef>
+          <a:fontRef idx="minor">
+            <a:schemeClr val="lt1"/>
+          </a:fontRef>
+        </p:style>
+        <p:txBody>
+          <a:bodyPr rtlCol="0" anchor="ctr"/>
+          <a:lstStyle/>
+          <a:p>
+            <a:pPr algn="ctr"/>
+          </a:p>
+        </p:txBody>
+      </p:sp>
+      <p:sp>
+        <p:nvSpPr>
+          <p:cNvPr id="8" name="Rectangle 7"/>
+          <p:cNvSpPr/>
+          <p:nvPr/>
+        </p:nvSpPr>
+        <p:spPr>
+          <a:xfrm>
+            <a:off x="4860036" y="3840552"/>
+            <a:ext cx="3826764" cy="1878275"/>
+          </a:xfrm>
+          <a:prstGeom prst="rect">
+            <a:avLst/>
+          </a:prstGeom>
+          <a:solidFill>
+            <a:srgbClr val="D0FFE4"/>
+          </a:solidFill>
+          <a:ln>
+            <a:noFill/>
+          </a:ln>
+        </p:spPr>
+        <p:style>
+          <a:lnRef idx="1">
+            <a:schemeClr val="accent1"/>
+          </a:lnRef>
+          <a:fillRef idx="3">
+            <a:schemeClr val="accent1"/>
+          </a:fillRef>
+          <a:effectRef idx="2">
+            <a:schemeClr val="accent1"/>
+          </a:effectRef>
+          <a:fontRef idx="minor">
+            <a:schemeClr val="lt1"/>
+          </a:fontRef>
+        </p:style>
+        <p:txBody>
+          <a:bodyPr rtlCol="0" anchor="ctr"/>
+          <a:lstStyle/>
+          <a:p>
+            <a:pPr algn="ctr"/>
+          </a:p>
+        </p:txBody>
+      </p:sp>
+      <p:sp>
+        <p:nvSpPr>
+          <p:cNvPr id="9" name="Rectangle 8"/>
+          <p:cNvSpPr/>
+          <p:nvPr/>
+        </p:nvSpPr>
+        <p:spPr>
+          <a:xfrm>
+            <a:off x="1033272" y="1962277"/>
+            <a:ext cx="7653528" cy="3756550"/>
+          </a:xfrm>
+          <a:prstGeom prst="rect">
+            <a:avLst/>
+          </a:prstGeom>
+          <a:noFill/>
+          <a:ln w="19050">
+            <a:solidFill>
+              <a:srgbClr val="646464"/>
+            </a:solidFill>
+          </a:ln>
+        </p:spPr>
+        <p:style>
+          <a:lnRef idx="1">
+            <a:schemeClr val="accent1"/>
+          </a:lnRef>
+          <a:fillRef idx="3">
+            <a:schemeClr val="accent1"/>
+          </a:fillRef>
+          <a:effectRef idx="2">
+            <a:schemeClr val="accent1"/>
+          </a:effectRef>
+          <a:fontRef idx="minor">
+            <a:schemeClr val="lt1"/>
+          </a:fontRef>
+        </p:style>
+        <p:txBody>
+          <a:bodyPr rtlCol="0" anchor="ctr"/>
+          <a:lstStyle/>
+          <a:p>
+            <a:pPr algn="ctr"/>
+          </a:p>
+        </p:txBody>
+      </p:sp>
+      <p:cxnSp>
+        <p:nvCxnSpPr>
+          <p:cNvPr id="10" name="Connector 9"/>
+          <p:cNvCxnSpPr/>
+          <p:nvPr/>
+        </p:nvCxnSpPr>
+        <p:spPr>
+          <a:xfrm>
+            <a:off x="1033272" y="3840552"/>
+            <a:ext cx="7653528" cy="0"/>
+          </a:xfrm>
+          <a:prstGeom prst="line">
+            <a:avLst/>
+          </a:prstGeom>
+          <a:ln w="12700">
+            <a:solidFill>
+              <a:srgbClr val="A0A0A0"/>
+            </a:solidFill>
+          </a:ln>
+        </p:spPr>
+        <p:style>
+          <a:lnRef idx="2">
+            <a:schemeClr val="accent1"/>
+          </a:lnRef>
+          <a:fillRef idx="0">
+            <a:schemeClr val="accent1"/>
+          </a:fillRef>
+          <a:effectRef idx="1">
+            <a:schemeClr val="accent1"/>
+          </a:effectRef>
+          <a:fontRef idx="minor">
+            <a:schemeClr val="tx1"/>
+          </a:fontRef>
+        </p:style>
+      </p:cxnSp>
+      <p:cxnSp>
+        <p:nvCxnSpPr>
+          <p:cNvPr id="11" name="Connector 10"/>
+          <p:cNvCxnSpPr/>
+          <p:nvPr/>
+        </p:nvCxnSpPr>
+        <p:spPr>
+          <a:xfrm>
+            <a:off x="4860036" y="1962277"/>
+            <a:ext cx="0" cy="3756550"/>
+          </a:xfrm>
+          <a:prstGeom prst="line">
+            <a:avLst/>
+          </a:prstGeom>
+          <a:ln w="12700">
+            <a:solidFill>
+              <a:srgbClr val="A0A0A0"/>
+            </a:solidFill>
+          </a:ln>
+        </p:spPr>
+        <p:style>
+          <a:lnRef idx="2">
+            <a:schemeClr val="accent1"/>
+          </a:lnRef>
+          <a:fillRef idx="0">
+            <a:schemeClr val="accent1"/>
+          </a:fillRef>
+          <a:effectRef idx="1">
+            <a:schemeClr val="accent1"/>
+          </a:effectRef>
+          <a:fontRef idx="minor">
+            <a:schemeClr val="tx1"/>
+          </a:fontRef>
+        </p:style>
+      </p:cxnSp>
+      <p:sp>
+        <p:nvSpPr>
+          <p:cNvPr id="12" name="TextBox 11"/>
+          <p:cNvSpPr txBox="1"/>
+          <p:nvPr/>
+        </p:nvSpPr>
+        <p:spPr>
+          <a:xfrm>
+            <a:off x="1083272" y="2012277"/>
+            <a:ext cx="3726764" cy="300000"/>
           </a:xfrm>
           <a:prstGeom prst="rect">
             <a:avLst/>
@@ -19097,22 +19416,568 @@
           </a:bodyPr>
           <a:lstStyle/>
           <a:p>
+            <a:pPr algn="ctr"/>
+            <a:r>
+              <a:rPr sz="1200" b="1">
+                <a:solidFill>
+                  <a:srgbClr val="2850A0"/>
+                </a:solidFill>
+              </a:rPr>
+              <a:t>問題児</a:t>
+            </a:r>
+          </a:p>
+        </p:txBody>
+      </p:sp>
+      <p:sp>
+        <p:nvSpPr>
+          <p:cNvPr id="13" name="TextBox 12"/>
+          <p:cNvSpPr txBox="1"/>
+          <p:nvPr/>
+        </p:nvSpPr>
+        <p:spPr>
+          <a:xfrm>
+            <a:off x="4910036" y="2012277"/>
+            <a:ext cx="3726764" cy="300000"/>
+          </a:xfrm>
+          <a:prstGeom prst="rect">
+            <a:avLst/>
+          </a:prstGeom>
+          <a:noFill/>
+        </p:spPr>
+        <p:txBody>
+          <a:bodyPr wrap="square">
+            <a:spAutoFit/>
+          </a:bodyPr>
+          <a:lstStyle/>
+          <a:p>
+            <a:pPr algn="ctr"/>
+            <a:r>
+              <a:rPr sz="1200" b="1">
+                <a:solidFill>
+                  <a:srgbClr val="503CA0"/>
+                </a:solidFill>
+              </a:rPr>
+              <a:t>スター</a:t>
+            </a:r>
+          </a:p>
+        </p:txBody>
+      </p:sp>
+      <p:sp>
+        <p:nvSpPr>
+          <p:cNvPr id="14" name="TextBox 13"/>
+          <p:cNvSpPr txBox="1"/>
+          <p:nvPr/>
+        </p:nvSpPr>
+        <p:spPr>
+          <a:xfrm>
+            <a:off x="1083272" y="3890552"/>
+            <a:ext cx="3726764" cy="300000"/>
+          </a:xfrm>
+          <a:prstGeom prst="rect">
+            <a:avLst/>
+          </a:prstGeom>
+          <a:noFill/>
+        </p:spPr>
+        <p:txBody>
+          <a:bodyPr wrap="square">
+            <a:spAutoFit/>
+          </a:bodyPr>
+          <a:lstStyle/>
+          <a:p>
+            <a:pPr algn="ctr"/>
+            <a:r>
+              <a:rPr sz="1200" b="1">
+                <a:solidFill>
+                  <a:srgbClr val="78641E"/>
+                </a:solidFill>
+              </a:rPr>
+              <a:t>負け犬</a:t>
+            </a:r>
+          </a:p>
+        </p:txBody>
+      </p:sp>
+      <p:sp>
+        <p:nvSpPr>
+          <p:cNvPr id="15" name="TextBox 14"/>
+          <p:cNvSpPr txBox="1"/>
+          <p:nvPr/>
+        </p:nvSpPr>
+        <p:spPr>
+          <a:xfrm>
+            <a:off x="4910036" y="3890552"/>
+            <a:ext cx="3726764" cy="300000"/>
+          </a:xfrm>
+          <a:prstGeom prst="rect">
+            <a:avLst/>
+          </a:prstGeom>
+          <a:noFill/>
+        </p:spPr>
+        <p:txBody>
+          <a:bodyPr wrap="square">
+            <a:spAutoFit/>
+          </a:bodyPr>
+          <a:lstStyle/>
+          <a:p>
+            <a:pPr algn="ctr"/>
+            <a:r>
+              <a:rPr sz="1200" b="1">
+                <a:solidFill>
+                  <a:srgbClr val="1E7846"/>
+                </a:solidFill>
+              </a:rPr>
+              <a:t>金のなる木</a:t>
+            </a:r>
+          </a:p>
+        </p:txBody>
+      </p:sp>
+      <p:sp>
+        <p:nvSpPr>
+          <p:cNvPr id="16" name="TextBox 15"/>
+          <p:cNvSpPr txBox="1"/>
+          <p:nvPr/>
+        </p:nvSpPr>
+        <p:spPr>
+          <a:xfrm>
+            <a:off x="1033272" y="5718827"/>
+            <a:ext cx="3826764" cy="407336"/>
+          </a:xfrm>
+          <a:prstGeom prst="rect">
+            <a:avLst/>
+          </a:prstGeom>
+          <a:noFill/>
+        </p:spPr>
+        <p:txBody>
+          <a:bodyPr wrap="none">
+            <a:spAutoFit/>
+          </a:bodyPr>
+          <a:lstStyle/>
+          <a:p>
+            <a:pPr algn="l"/>
+            <a:r>
+              <a:rPr sz="1100">
+                <a:solidFill>
+                  <a:srgbClr val="505064"/>
+                </a:solidFill>
+              </a:rPr>
+              <a:t>低成長</a:t>
+            </a:r>
+          </a:p>
+        </p:txBody>
+      </p:sp>
+      <p:sp>
+        <p:nvSpPr>
+          <p:cNvPr id="17" name="TextBox 16"/>
+          <p:cNvSpPr txBox="1"/>
+          <p:nvPr/>
+        </p:nvSpPr>
+        <p:spPr>
+          <a:xfrm>
+            <a:off x="4860036" y="5718827"/>
+            <a:ext cx="3826764" cy="407336"/>
+          </a:xfrm>
+          <a:prstGeom prst="rect">
+            <a:avLst/>
+          </a:prstGeom>
+          <a:noFill/>
+        </p:spPr>
+        <p:txBody>
+          <a:bodyPr wrap="none">
+            <a:spAutoFit/>
+          </a:bodyPr>
+          <a:lstStyle/>
+          <a:p>
+            <a:pPr algn="r"/>
+            <a:r>
+              <a:rPr sz="1100">
+                <a:solidFill>
+                  <a:srgbClr val="505064"/>
+                </a:solidFill>
+              </a:rPr>
+              <a:t>高成長</a:t>
+            </a:r>
+          </a:p>
+        </p:txBody>
+      </p:sp>
+      <p:sp>
+        <p:nvSpPr>
+          <p:cNvPr id="18" name="TextBox 17"/>
+          <p:cNvSpPr txBox="1"/>
+          <p:nvPr/>
+        </p:nvSpPr>
+        <p:spPr>
+          <a:xfrm rot="16200000">
+            <a:off x="-193901" y="4501653"/>
+            <a:ext cx="1878275" cy="556072"/>
+          </a:xfrm>
+          <a:prstGeom prst="rect">
+            <a:avLst/>
+          </a:prstGeom>
+          <a:noFill/>
+        </p:spPr>
+        <p:txBody>
+          <a:bodyPr wrap="none">
+            <a:spAutoFit/>
+          </a:bodyPr>
+          <a:lstStyle/>
+          <a:p>
+            <a:pPr algn="l"/>
+            <a:r>
+              <a:rPr sz="1100">
+                <a:solidFill>
+                  <a:srgbClr val="505064"/>
+                </a:solidFill>
+              </a:rPr>
+              <a:t>低シェア</a:t>
+            </a:r>
+          </a:p>
+        </p:txBody>
+      </p:sp>
+      <p:sp>
+        <p:nvSpPr>
+          <p:cNvPr id="19" name="TextBox 18"/>
+          <p:cNvSpPr txBox="1"/>
+          <p:nvPr/>
+        </p:nvSpPr>
+        <p:spPr>
+          <a:xfrm rot="16200000">
+            <a:off x="-193901" y="2623378"/>
+            <a:ext cx="1878275" cy="556072"/>
+          </a:xfrm>
+          <a:prstGeom prst="rect">
+            <a:avLst/>
+          </a:prstGeom>
+          <a:noFill/>
+        </p:spPr>
+        <p:txBody>
+          <a:bodyPr wrap="none">
+            <a:spAutoFit/>
+          </a:bodyPr>
+          <a:lstStyle/>
+          <a:p>
+            <a:pPr algn="l"/>
+            <a:r>
+              <a:rPr sz="1100">
+                <a:solidFill>
+                  <a:srgbClr val="505064"/>
+                </a:solidFill>
+              </a:rPr>
+              <a:t>高シェア</a:t>
+            </a:r>
+          </a:p>
+        </p:txBody>
+      </p:sp>
+      <p:sp>
+        <p:nvSpPr>
+          <p:cNvPr id="20" name="Oval 19"/>
+          <p:cNvSpPr/>
+          <p:nvPr/>
+        </p:nvSpPr>
+        <p:spPr>
+          <a:xfrm>
+            <a:off x="6343116" y="2665961"/>
+            <a:ext cx="95250" cy="95250"/>
+          </a:xfrm>
+          <a:prstGeom prst="ellipse">
+            <a:avLst/>
+          </a:prstGeom>
+          <a:solidFill>
+            <a:srgbClr val="808080"/>
+          </a:solidFill>
+          <a:ln w="9525">
+            <a:solidFill>
+              <a:srgbClr val="505050"/>
+            </a:solidFill>
+          </a:ln>
+        </p:spPr>
+        <p:style>
+          <a:lnRef idx="1">
+            <a:schemeClr val="accent1"/>
+          </a:lnRef>
+          <a:fillRef idx="3">
+            <a:schemeClr val="accent1"/>
+          </a:fillRef>
+          <a:effectRef idx="2">
+            <a:schemeClr val="accent1"/>
+          </a:effectRef>
+          <a:fontRef idx="minor">
+            <a:schemeClr val="lt1"/>
+          </a:fontRef>
+        </p:style>
+        <p:txBody>
+          <a:bodyPr rtlCol="0" anchor="ctr"/>
+          <a:lstStyle/>
+          <a:p>
+            <a:pPr algn="ctr"/>
+          </a:p>
+        </p:txBody>
+      </p:sp>
+      <p:sp>
+        <p:nvSpPr>
+          <p:cNvPr id="21" name="TextBox 20"/>
+          <p:cNvSpPr txBox="1"/>
+          <p:nvPr/>
+        </p:nvSpPr>
+        <p:spPr>
+          <a:xfrm>
+            <a:off x="5990741" y="2786211"/>
+            <a:ext cx="800000" cy="200000"/>
+          </a:xfrm>
+          <a:prstGeom prst="rect">
+            <a:avLst/>
+          </a:prstGeom>
+          <a:noFill/>
+        </p:spPr>
+        <p:txBody>
+          <a:bodyPr wrap="none">
+            <a:spAutoFit/>
+          </a:bodyPr>
+          <a:lstStyle/>
+          <a:p>
+            <a:pPr algn="ctr"/>
             <a:r>
               <a:rPr sz="1000">
-                <a:latin typeface="Courier New"/>
+                <a:solidFill>
+                  <a:srgbClr val="323232"/>
+                </a:solidFill>
               </a:rPr>
-              <a:t>quadrantChart
-    title 製品ポートフォリオ分析
-    x-axis 低成長 --&gt; 高成長
-    y-axis 低シェア --&gt; 高シェア
-    quadrant-1 スター
-    quadrant-2 問題児
-    quadrant-3 負け犬
-    quadrant-4 金のなる木
-    製品A: [0.7, 0.8]
-    製品B: [0.3, 0.7]
-    製品C: [0.2, 0.3]
-    製品D: [0.8, 0.3]</a:t>
+              <a:t>製品A</a:t>
+            </a:r>
+          </a:p>
+        </p:txBody>
+      </p:sp>
+      <p:sp>
+        <p:nvSpPr>
+          <p:cNvPr id="22" name="Oval 21"/>
+          <p:cNvSpPr/>
+          <p:nvPr/>
+        </p:nvSpPr>
+        <p:spPr>
+          <a:xfrm>
+            <a:off x="3281705" y="3041617"/>
+            <a:ext cx="95250" cy="95250"/>
+          </a:xfrm>
+          <a:prstGeom prst="ellipse">
+            <a:avLst/>
+          </a:prstGeom>
+          <a:solidFill>
+            <a:srgbClr val="808080"/>
+          </a:solidFill>
+          <a:ln w="9525">
+            <a:solidFill>
+              <a:srgbClr val="505050"/>
+            </a:solidFill>
+          </a:ln>
+        </p:spPr>
+        <p:style>
+          <a:lnRef idx="1">
+            <a:schemeClr val="accent1"/>
+          </a:lnRef>
+          <a:fillRef idx="3">
+            <a:schemeClr val="accent1"/>
+          </a:fillRef>
+          <a:effectRef idx="2">
+            <a:schemeClr val="accent1"/>
+          </a:effectRef>
+          <a:fontRef idx="minor">
+            <a:schemeClr val="lt1"/>
+          </a:fontRef>
+        </p:style>
+        <p:txBody>
+          <a:bodyPr rtlCol="0" anchor="ctr"/>
+          <a:lstStyle/>
+          <a:p>
+            <a:pPr algn="ctr"/>
+          </a:p>
+        </p:txBody>
+      </p:sp>
+      <p:sp>
+        <p:nvSpPr>
+          <p:cNvPr id="23" name="TextBox 22"/>
+          <p:cNvSpPr txBox="1"/>
+          <p:nvPr/>
+        </p:nvSpPr>
+        <p:spPr>
+          <a:xfrm>
+            <a:off x="2929330" y="3161867"/>
+            <a:ext cx="800000" cy="200000"/>
+          </a:xfrm>
+          <a:prstGeom prst="rect">
+            <a:avLst/>
+          </a:prstGeom>
+          <a:noFill/>
+        </p:spPr>
+        <p:txBody>
+          <a:bodyPr wrap="none">
+            <a:spAutoFit/>
+          </a:bodyPr>
+          <a:lstStyle/>
+          <a:p>
+            <a:pPr algn="ctr"/>
+            <a:r>
+              <a:rPr sz="1000">
+                <a:solidFill>
+                  <a:srgbClr val="323232"/>
+                </a:solidFill>
+              </a:rPr>
+              <a:t>製品B</a:t>
+            </a:r>
+          </a:p>
+        </p:txBody>
+      </p:sp>
+      <p:sp>
+        <p:nvSpPr>
+          <p:cNvPr id="24" name="Oval 23"/>
+          <p:cNvSpPr/>
+          <p:nvPr/>
+        </p:nvSpPr>
+        <p:spPr>
+          <a:xfrm>
+            <a:off x="2516352" y="4544237"/>
+            <a:ext cx="95250" cy="95250"/>
+          </a:xfrm>
+          <a:prstGeom prst="ellipse">
+            <a:avLst/>
+          </a:prstGeom>
+          <a:solidFill>
+            <a:srgbClr val="808080"/>
+          </a:solidFill>
+          <a:ln w="9525">
+            <a:solidFill>
+              <a:srgbClr val="505050"/>
+            </a:solidFill>
+          </a:ln>
+        </p:spPr>
+        <p:style>
+          <a:lnRef idx="1">
+            <a:schemeClr val="accent1"/>
+          </a:lnRef>
+          <a:fillRef idx="3">
+            <a:schemeClr val="accent1"/>
+          </a:fillRef>
+          <a:effectRef idx="2">
+            <a:schemeClr val="accent1"/>
+          </a:effectRef>
+          <a:fontRef idx="minor">
+            <a:schemeClr val="lt1"/>
+          </a:fontRef>
+        </p:style>
+        <p:txBody>
+          <a:bodyPr rtlCol="0" anchor="ctr"/>
+          <a:lstStyle/>
+          <a:p>
+            <a:pPr algn="ctr"/>
+          </a:p>
+        </p:txBody>
+      </p:sp>
+      <p:sp>
+        <p:nvSpPr>
+          <p:cNvPr id="25" name="TextBox 24"/>
+          <p:cNvSpPr txBox="1"/>
+          <p:nvPr/>
+        </p:nvSpPr>
+        <p:spPr>
+          <a:xfrm>
+            <a:off x="2163977" y="4664487"/>
+            <a:ext cx="800000" cy="200000"/>
+          </a:xfrm>
+          <a:prstGeom prst="rect">
+            <a:avLst/>
+          </a:prstGeom>
+          <a:noFill/>
+        </p:spPr>
+        <p:txBody>
+          <a:bodyPr wrap="none">
+            <a:spAutoFit/>
+          </a:bodyPr>
+          <a:lstStyle/>
+          <a:p>
+            <a:pPr algn="ctr"/>
+            <a:r>
+              <a:rPr sz="1000">
+                <a:solidFill>
+                  <a:srgbClr val="323232"/>
+                </a:solidFill>
+              </a:rPr>
+              <a:t>製品C</a:t>
+            </a:r>
+          </a:p>
+        </p:txBody>
+      </p:sp>
+      <p:sp>
+        <p:nvSpPr>
+          <p:cNvPr id="26" name="Oval 25"/>
+          <p:cNvSpPr/>
+          <p:nvPr/>
+        </p:nvSpPr>
+        <p:spPr>
+          <a:xfrm>
+            <a:off x="7108469" y="4544237"/>
+            <a:ext cx="95250" cy="95250"/>
+          </a:xfrm>
+          <a:prstGeom prst="ellipse">
+            <a:avLst/>
+          </a:prstGeom>
+          <a:solidFill>
+            <a:srgbClr val="808080"/>
+          </a:solidFill>
+          <a:ln w="9525">
+            <a:solidFill>
+              <a:srgbClr val="505050"/>
+            </a:solidFill>
+          </a:ln>
+        </p:spPr>
+        <p:style>
+          <a:lnRef idx="1">
+            <a:schemeClr val="accent1"/>
+          </a:lnRef>
+          <a:fillRef idx="3">
+            <a:schemeClr val="accent1"/>
+          </a:fillRef>
+          <a:effectRef idx="2">
+            <a:schemeClr val="accent1"/>
+          </a:effectRef>
+          <a:fontRef idx="minor">
+            <a:schemeClr val="lt1"/>
+          </a:fontRef>
+        </p:style>
+        <p:txBody>
+          <a:bodyPr rtlCol="0" anchor="ctr"/>
+          <a:lstStyle/>
+          <a:p>
+            <a:pPr algn="ctr"/>
+          </a:p>
+        </p:txBody>
+      </p:sp>
+      <p:sp>
+        <p:nvSpPr>
+          <p:cNvPr id="27" name="TextBox 26"/>
+          <p:cNvSpPr txBox="1"/>
+          <p:nvPr/>
+        </p:nvSpPr>
+        <p:spPr>
+          <a:xfrm>
+            <a:off x="6756094" y="4664487"/>
+            <a:ext cx="800000" cy="200000"/>
+          </a:xfrm>
+          <a:prstGeom prst="rect">
+            <a:avLst/>
+          </a:prstGeom>
+          <a:noFill/>
+        </p:spPr>
+        <p:txBody>
+          <a:bodyPr wrap="none">
+            <a:spAutoFit/>
+          </a:bodyPr>
+          <a:lstStyle/>
+          <a:p>
+            <a:pPr algn="ctr"/>
+            <a:r>
+              <a:rPr sz="1000">
+                <a:solidFill>
+                  <a:srgbClr val="323232"/>
+                </a:solidFill>
+              </a:rPr>
+              <a:t>製品D</a:t>
             </a:r>
           </a:p>
         </p:txBody>

</xml_diff>

<commit_message>
Add comprehensive tests for requirement diagram parser and renderer
- Implemented tests for parsing various requirement types including basic requirements, functional requirements, interface requirements, and more.
- Added tests for element nodes and their properties, including handling of docref and Japanese text.
- Included tests for parsing relationships with different types such as contains, traces, copies, and verifies.
- Developed tests for direction settings and style parsing, ensuring correct application of styles and class definitions.
- Created tests for inline markdown parsing to validate formatting.
- Established rendering tests for the RequirementRenderer to ensure shapes and connectors are drawn correctly, including handling of Japanese text and various relation types.
- Ensured that edge cases, such as empty diagrams and unknown relation nodes, are handled without errors.
</commit_message>
<xml_diff>
--- a/demo_full.pptx
+++ b/demo_full.pptx
@@ -20045,46 +20045,509 @@
           <a:p/>
         </p:txBody>
       </p:sp>
-      <p:sp>
-        <p:nvSpPr>
-          <p:cNvPr id="4" name="TextBox 3"/>
+      <p:grpSp>
+        <p:nvGrpSpPr>
+          <p:cNvPr id="7" name="Group 6"/>
+          <p:cNvGrpSpPr/>
+          <p:nvPr/>
+        </p:nvGrpSpPr>
+        <p:grpSpPr>
+          <a:xfrm>
+            <a:off x="2372000" y="2933181"/>
+            <a:ext cx="2000000" cy="1860000"/>
+            <a:chOff x="2372000" y="2933181"/>
+            <a:chExt cx="2000000" cy="1860000"/>
+          </a:xfrm>
+        </p:grpSpPr>
+        <p:sp>
+          <p:nvSpPr>
+            <p:cNvPr id="4" name="Rectangle 3"/>
+            <p:cNvSpPr/>
+            <p:nvPr/>
+          </p:nvSpPr>
+          <p:spPr>
+            <a:xfrm>
+              <a:off x="2372000" y="2933181"/>
+              <a:ext cx="2000000" cy="320000"/>
+            </a:xfrm>
+            <a:prstGeom prst="rect">
+              <a:avLst/>
+            </a:prstGeom>
+            <a:solidFill>
+              <a:srgbClr val="A0C8F0"/>
+            </a:solidFill>
+            <a:ln w="12700">
+              <a:solidFill>
+                <a:srgbClr val="646E82"/>
+              </a:solidFill>
+            </a:ln>
+          </p:spPr>
+          <p:style>
+            <a:lnRef idx="1">
+              <a:schemeClr val="accent1"/>
+            </a:lnRef>
+            <a:fillRef idx="3">
+              <a:schemeClr val="accent1"/>
+            </a:fillRef>
+            <a:effectRef idx="2">
+              <a:schemeClr val="accent1"/>
+            </a:effectRef>
+            <a:fontRef idx="minor">
+              <a:schemeClr val="lt1"/>
+            </a:fontRef>
+          </p:style>
+          <p:txBody>
+            <a:bodyPr rtlCol="0" anchor="ctr" lIns="60000" rIns="60000" tIns="30000" bIns="30000"/>
+            <a:lstStyle/>
+            <a:p>
+              <a:pPr algn="ctr"/>
+              <a:r>
+                <a:rPr sz="900" i="1">
+                  <a:solidFill>
+                    <a:srgbClr val="1E1E3C"/>
+                  </a:solidFill>
+                </a:rPr>
+                <a:t>&lt;&lt;Requirement&gt;&gt;</a:t>
+              </a:r>
+            </a:p>
+          </p:txBody>
+        </p:sp>
+        <p:sp>
+          <p:nvSpPr>
+            <p:cNvPr id="5" name="Rectangle 4"/>
+            <p:cNvSpPr/>
+            <p:nvPr/>
+          </p:nvSpPr>
+          <p:spPr>
+            <a:xfrm>
+              <a:off x="2372000" y="3253181"/>
+              <a:ext cx="2000000" cy="380000"/>
+            </a:xfrm>
+            <a:prstGeom prst="rect">
+              <a:avLst/>
+            </a:prstGeom>
+            <a:solidFill>
+              <a:srgbClr val="D0E8FF"/>
+            </a:solidFill>
+            <a:ln w="12700">
+              <a:solidFill>
+                <a:srgbClr val="646E82"/>
+              </a:solidFill>
+            </a:ln>
+          </p:spPr>
+          <p:style>
+            <a:lnRef idx="1">
+              <a:schemeClr val="accent1"/>
+            </a:lnRef>
+            <a:fillRef idx="3">
+              <a:schemeClr val="accent1"/>
+            </a:fillRef>
+            <a:effectRef idx="2">
+              <a:schemeClr val="accent1"/>
+            </a:effectRef>
+            <a:fontRef idx="minor">
+              <a:schemeClr val="lt1"/>
+            </a:fontRef>
+          </p:style>
+          <p:txBody>
+            <a:bodyPr rtlCol="0" anchor="ctr" lIns="60000" rIns="60000" tIns="40000" bIns="40000"/>
+            <a:lstStyle/>
+            <a:p>
+              <a:pPr algn="ctr"/>
+              <a:r>
+                <a:rPr sz="1100" b="1" i="0">
+                  <a:solidFill>
+                    <a:srgbClr val="1E1E3C"/>
+                  </a:solidFill>
+                </a:rPr>
+                <a:t>test_req</a:t>
+              </a:r>
+            </a:p>
+          </p:txBody>
+        </p:sp>
+        <p:sp>
+          <p:nvSpPr>
+            <p:cNvPr id="6" name="Rectangle 5"/>
+            <p:cNvSpPr/>
+            <p:nvPr/>
+          </p:nvSpPr>
+          <p:spPr>
+            <a:xfrm>
+              <a:off x="2372000" y="3633181"/>
+              <a:ext cx="2000000" cy="1160000"/>
+            </a:xfrm>
+            <a:prstGeom prst="rect">
+              <a:avLst/>
+            </a:prstGeom>
+            <a:solidFill>
+              <a:srgbClr val="EEF7FF"/>
+            </a:solidFill>
+            <a:ln w="12700">
+              <a:solidFill>
+                <a:srgbClr val="646E82"/>
+              </a:solidFill>
+            </a:ln>
+          </p:spPr>
+          <p:style>
+            <a:lnRef idx="1">
+              <a:schemeClr val="accent1"/>
+            </a:lnRef>
+            <a:fillRef idx="3">
+              <a:schemeClr val="accent1"/>
+            </a:fillRef>
+            <a:effectRef idx="2">
+              <a:schemeClr val="accent1"/>
+            </a:effectRef>
+            <a:fontRef idx="minor">
+              <a:schemeClr val="lt1"/>
+            </a:fontRef>
+          </p:style>
+          <p:txBody>
+            <a:bodyPr rtlCol="0" anchor="ctr" wrap="square" lIns="80000" rIns="60000" tIns="40000" bIns="40000"/>
+            <a:lstStyle/>
+            <a:p>
+              <a:pPr algn="l"/>
+              <a:r>
+                <a:rPr sz="900" b="0">
+                  <a:solidFill>
+                    <a:srgbClr val="282828"/>
+                  </a:solidFill>
+                </a:rPr>
+                <a:t>ID: 1</a:t>
+              </a:r>
+            </a:p>
+            <a:p>
+              <a:pPr algn="l"/>
+              <a:r>
+                <a:rPr sz="900" b="0">
+                  <a:solidFill>
+                    <a:srgbClr val="282828"/>
+                  </a:solidFill>
+                </a:rPr>
+                <a:t>Text: </a:t>
+              </a:r>
+              <a:r>
+                <a:rPr sz="900" b="0" i="0">
+                  <a:solidFill>
+                    <a:srgbClr val="282828"/>
+                  </a:solidFill>
+                </a:rPr>
+                <a:t>システムは99.9%の可用性を持つこと</a:t>
+              </a:r>
+            </a:p>
+            <a:p>
+              <a:pPr algn="l"/>
+              <a:r>
+                <a:rPr sz="900" b="0">
+                  <a:solidFill>
+                    <a:srgbClr val="282828"/>
+                  </a:solidFill>
+                </a:rPr>
+                <a:t>Risk: High</a:t>
+              </a:r>
+            </a:p>
+            <a:p>
+              <a:pPr algn="l"/>
+              <a:r>
+                <a:rPr sz="900" b="0">
+                  <a:solidFill>
+                    <a:srgbClr val="282828"/>
+                  </a:solidFill>
+                </a:rPr>
+                <a:t>Verification: Test</a:t>
+              </a:r>
+            </a:p>
+          </p:txBody>
+        </p:sp>
+      </p:grpSp>
+      <p:grpSp>
+        <p:nvGrpSpPr>
+          <p:cNvPr id="11" name="Group 10"/>
+          <p:cNvGrpSpPr/>
+          <p:nvPr/>
+        </p:nvGrpSpPr>
+        <p:grpSpPr>
+          <a:xfrm>
+            <a:off x="4772000" y="2933181"/>
+            <a:ext cx="2000000" cy="1860000"/>
+            <a:chOff x="4772000" y="2933181"/>
+            <a:chExt cx="2000000" cy="1860000"/>
+          </a:xfrm>
+        </p:grpSpPr>
+        <p:sp>
+          <p:nvSpPr>
+            <p:cNvPr id="8" name="Rectangle 7"/>
+            <p:cNvSpPr/>
+            <p:nvPr/>
+          </p:nvSpPr>
+          <p:spPr>
+            <a:xfrm>
+              <a:off x="4772000" y="2933181"/>
+              <a:ext cx="2000000" cy="320000"/>
+            </a:xfrm>
+            <a:prstGeom prst="rect">
+              <a:avLst/>
+            </a:prstGeom>
+            <a:solidFill>
+              <a:srgbClr val="C8A0F0"/>
+            </a:solidFill>
+            <a:ln w="12700">
+              <a:solidFill>
+                <a:srgbClr val="646E82"/>
+              </a:solidFill>
+            </a:ln>
+          </p:spPr>
+          <p:style>
+            <a:lnRef idx="1">
+              <a:schemeClr val="accent1"/>
+            </a:lnRef>
+            <a:fillRef idx="3">
+              <a:schemeClr val="accent1"/>
+            </a:fillRef>
+            <a:effectRef idx="2">
+              <a:schemeClr val="accent1"/>
+            </a:effectRef>
+            <a:fontRef idx="minor">
+              <a:schemeClr val="lt1"/>
+            </a:fontRef>
+          </p:style>
+          <p:txBody>
+            <a:bodyPr rtlCol="0" anchor="ctr" lIns="60000" rIns="60000" tIns="30000" bIns="30000"/>
+            <a:lstStyle/>
+            <a:p>
+              <a:pPr algn="ctr"/>
+              <a:r>
+                <a:rPr sz="900" i="1">
+                  <a:solidFill>
+                    <a:srgbClr val="1E1E3C"/>
+                  </a:solidFill>
+                </a:rPr>
+                <a:t>&lt;&lt;Functional Requirement&gt;&gt;</a:t>
+              </a:r>
+            </a:p>
+          </p:txBody>
+        </p:sp>
+        <p:sp>
+          <p:nvSpPr>
+            <p:cNvPr id="9" name="Rectangle 8"/>
+            <p:cNvSpPr/>
+            <p:nvPr/>
+          </p:nvSpPr>
+          <p:spPr>
+            <a:xfrm>
+              <a:off x="4772000" y="3253181"/>
+              <a:ext cx="2000000" cy="380000"/>
+            </a:xfrm>
+            <a:prstGeom prst="rect">
+              <a:avLst/>
+            </a:prstGeom>
+            <a:solidFill>
+              <a:srgbClr val="E8D0FF"/>
+            </a:solidFill>
+            <a:ln w="12700">
+              <a:solidFill>
+                <a:srgbClr val="646E82"/>
+              </a:solidFill>
+            </a:ln>
+          </p:spPr>
+          <p:style>
+            <a:lnRef idx="1">
+              <a:schemeClr val="accent1"/>
+            </a:lnRef>
+            <a:fillRef idx="3">
+              <a:schemeClr val="accent1"/>
+            </a:fillRef>
+            <a:effectRef idx="2">
+              <a:schemeClr val="accent1"/>
+            </a:effectRef>
+            <a:fontRef idx="minor">
+              <a:schemeClr val="lt1"/>
+            </a:fontRef>
+          </p:style>
+          <p:txBody>
+            <a:bodyPr rtlCol="0" anchor="ctr" lIns="60000" rIns="60000" tIns="40000" bIns="40000"/>
+            <a:lstStyle/>
+            <a:p>
+              <a:pPr algn="ctr"/>
+              <a:r>
+                <a:rPr sz="1100" b="1" i="0">
+                  <a:solidFill>
+                    <a:srgbClr val="1E1E3C"/>
+                  </a:solidFill>
+                </a:rPr>
+                <a:t>login_req</a:t>
+              </a:r>
+            </a:p>
+          </p:txBody>
+        </p:sp>
+        <p:sp>
+          <p:nvSpPr>
+            <p:cNvPr id="10" name="Rectangle 9"/>
+            <p:cNvSpPr/>
+            <p:nvPr/>
+          </p:nvSpPr>
+          <p:spPr>
+            <a:xfrm>
+              <a:off x="4772000" y="3633181"/>
+              <a:ext cx="2000000" cy="1160000"/>
+            </a:xfrm>
+            <a:prstGeom prst="rect">
+              <a:avLst/>
+            </a:prstGeom>
+            <a:solidFill>
+              <a:srgbClr val="F7EEFF"/>
+            </a:solidFill>
+            <a:ln w="12700">
+              <a:solidFill>
+                <a:srgbClr val="646E82"/>
+              </a:solidFill>
+            </a:ln>
+          </p:spPr>
+          <p:style>
+            <a:lnRef idx="1">
+              <a:schemeClr val="accent1"/>
+            </a:lnRef>
+            <a:fillRef idx="3">
+              <a:schemeClr val="accent1"/>
+            </a:fillRef>
+            <a:effectRef idx="2">
+              <a:schemeClr val="accent1"/>
+            </a:effectRef>
+            <a:fontRef idx="minor">
+              <a:schemeClr val="lt1"/>
+            </a:fontRef>
+          </p:style>
+          <p:txBody>
+            <a:bodyPr rtlCol="0" anchor="ctr" wrap="square" lIns="80000" rIns="60000" tIns="40000" bIns="40000"/>
+            <a:lstStyle/>
+            <a:p>
+              <a:pPr algn="l"/>
+              <a:r>
+                <a:rPr sz="900" b="0">
+                  <a:solidFill>
+                    <a:srgbClr val="282828"/>
+                  </a:solidFill>
+                </a:rPr>
+                <a:t>ID: 2</a:t>
+              </a:r>
+            </a:p>
+            <a:p>
+              <a:pPr algn="l"/>
+              <a:r>
+                <a:rPr sz="900" b="0">
+                  <a:solidFill>
+                    <a:srgbClr val="282828"/>
+                  </a:solidFill>
+                </a:rPr>
+                <a:t>Text: </a:t>
+              </a:r>
+              <a:r>
+                <a:rPr sz="900" b="0" i="0">
+                  <a:solidFill>
+                    <a:srgbClr val="282828"/>
+                  </a:solidFill>
+                </a:rPr>
+                <a:t>ユーザーはログインできること</a:t>
+              </a:r>
+            </a:p>
+            <a:p>
+              <a:pPr algn="l"/>
+              <a:r>
+                <a:rPr sz="900" b="0">
+                  <a:solidFill>
+                    <a:srgbClr val="282828"/>
+                  </a:solidFill>
+                </a:rPr>
+                <a:t>Risk: Medium</a:t>
+              </a:r>
+            </a:p>
+            <a:p>
+              <a:pPr algn="l"/>
+              <a:r>
+                <a:rPr sz="900" b="0">
+                  <a:solidFill>
+                    <a:srgbClr val="282828"/>
+                  </a:solidFill>
+                </a:rPr>
+                <a:t>Verification: Inspection</a:t>
+              </a:r>
+            </a:p>
+          </p:txBody>
+        </p:sp>
+      </p:grpSp>
+      <p:cxnSp>
+        <p:nvCxnSpPr>
+          <p:cNvPr id="12" name="Connector 11"/>
+          <p:cNvCxnSpPr>
+            <a:stCxn id="5" idx="3"/>
+            <a:endCxn id="9" idx="1"/>
+          </p:cNvCxnSpPr>
+          <p:nvPr/>
+        </p:nvCxnSpPr>
+        <p:spPr>
+          <a:xfrm>
+            <a:off x="4372000" y="3443181"/>
+            <a:ext cx="400000" cy="0"/>
+          </a:xfrm>
+          <a:prstGeom prst="line">
+            <a:avLst/>
+          </a:prstGeom>
+          <a:ln w="12700">
+            <a:solidFill>
+              <a:srgbClr val="505A6E"/>
+            </a:solidFill>
+            <a:headEnd type="arrow" w="med" len="med"/>
+            <a:tailEnd type="none"/>
+          </a:ln>
+        </p:spPr>
+        <p:style>
+          <a:lnRef idx="2">
+            <a:schemeClr val="accent1"/>
+          </a:lnRef>
+          <a:fillRef idx="0">
+            <a:schemeClr val="accent1"/>
+          </a:fillRef>
+          <a:effectRef idx="1">
+            <a:schemeClr val="accent1"/>
+          </a:effectRef>
+          <a:fontRef idx="minor">
+            <a:schemeClr val="tx1"/>
+          </a:fontRef>
+        </p:style>
+      </p:cxnSp>
+      <p:sp>
+        <p:nvSpPr>
+          <p:cNvPr id="13" name="TextBox 12"/>
           <p:cNvSpPr txBox="1"/>
           <p:nvPr/>
         </p:nvSpPr>
         <p:spPr>
           <a:xfrm>
-            <a:off x="457200" y="1600200"/>
-            <a:ext cx="8229600" cy="4525963"/>
+            <a:off x="4172000" y="3318181"/>
+            <a:ext cx="800000" cy="250000"/>
           </a:xfrm>
           <a:prstGeom prst="rect">
             <a:avLst/>
           </a:prstGeom>
           <a:noFill/>
-        </p:spPr>
-        <p:txBody>
-          <a:bodyPr wrap="square">
+          <a:ln>
+            <a:noFill/>
+          </a:ln>
+        </p:spPr>
+        <p:txBody>
+          <a:bodyPr wrap="none">
             <a:spAutoFit/>
           </a:bodyPr>
           <a:lstStyle/>
           <a:p>
-            <a:r>
-              <a:rPr sz="1000">
-                <a:latin typeface="Courier New"/>
+            <a:pPr algn="ctr"/>
+            <a:r>
+              <a:rPr sz="900" i="1">
+                <a:solidFill>
+                  <a:srgbClr val="3C3C50"/>
+                </a:solidFill>
               </a:rPr>
-              <a:t>requirementDiagram
-    requirement test_req {
-        id: 1
-        text: システムは99.9%の可用性を持つこと
-        risk: high
-        verifymethod: test
-    }
-    functionalRequirement login_req {
-        id: 2
-        text: ユーザーはログインできること
-        risk: medium
-        verifymethod: inspection
-    }
-    test_req - traces -&gt; login_req</a:t>
+              <a:t>«traces»</a:t>
             </a:r>
           </a:p>
         </p:txBody>

</xml_diff>